<commit_message>
refactor: human-crafted presentation deck and submission whitepaper, fixed PDF glyph dots
</commit_message>
<xml_diff>
--- a/NeuroVocal_AI_Hackathon_Pitch.pptx
+++ b/NeuroVocal_AI_Hackathon_Pitch.pptx
@@ -3109,7 +3109,7 @@
             <a:avLst/>
           </a:prstGeom>
           <a:solidFill>
-            <a:srgbClr val="090D16"/>
+            <a:srgbClr val="0F172A"/>
           </a:solidFill>
           <a:ln>
             <a:noFill/>
@@ -3139,14 +3139,69 @@
       </p:sp>
       <p:sp>
         <p:nvSpPr>
-          <p:cNvPr id="3" name="TextBox 2"/>
+          <p:cNvPr id="3" name="Rounded Rectangle 2"/>
+          <p:cNvSpPr/>
+          <p:nvPr/>
+        </p:nvSpPr>
+        <p:spPr>
+          <a:xfrm>
+            <a:off x="1097280" y="1371600"/>
+            <a:ext cx="4114800" cy="411480"/>
+          </a:xfrm>
+          <a:prstGeom prst="roundRect">
+            <a:avLst/>
+          </a:prstGeom>
+          <a:solidFill>
+            <a:srgbClr val="1E293B"/>
+          </a:solidFill>
+          <a:ln w="12700">
+            <a:solidFill>
+              <a:srgbClr val="38BDF8"/>
+            </a:solidFill>
+          </a:ln>
+        </p:spPr>
+        <p:style>
+          <a:lnRef idx="1">
+            <a:schemeClr val="accent1"/>
+          </a:lnRef>
+          <a:fillRef idx="3">
+            <a:schemeClr val="accent1"/>
+          </a:fillRef>
+          <a:effectRef idx="2">
+            <a:schemeClr val="accent1"/>
+          </a:effectRef>
+          <a:fontRef idx="minor">
+            <a:schemeClr val="lt1"/>
+          </a:fontRef>
+        </p:style>
+        <p:txBody>
+          <a:bodyPr rtlCol="0" anchor="ctr"/>
+          <a:lstStyle/>
+          <a:p>
+            <a:pPr algn="ctr">
+              <a:defRPr sz="1100" b="1">
+                <a:solidFill>
+                  <a:srgbClr val="38BDF8"/>
+                </a:solidFill>
+                <a:latin typeface="Calibri"/>
+              </a:defRPr>
+            </a:pPr>
+            <a:r>
+              <a:t>HACKERING 2.0  |  REAL-TIME VOICE AI TRACK</a:t>
+            </a:r>
+          </a:p>
+        </p:txBody>
+      </p:sp>
+      <p:sp>
+        <p:nvSpPr>
+          <p:cNvPr id="4" name="TextBox 3"/>
           <p:cNvSpPr txBox="1"/>
           <p:nvPr/>
         </p:nvSpPr>
         <p:spPr>
           <a:xfrm>
-            <a:off x="731520" y="457200"/>
-            <a:ext cx="10698480" cy="365760"/>
+            <a:off x="1097280" y="2011680"/>
+            <a:ext cx="10058400" cy="1463040"/>
           </a:xfrm>
           <a:prstGeom prst="rect">
             <a:avLst/>
@@ -3160,29 +3215,120 @@
           <a:lstStyle/>
           <a:p>
             <a:pPr>
-              <a:defRPr sz="1100" b="1">
-                <a:solidFill>
-                  <a:srgbClr val="06B6D4"/>
-                </a:solidFill>
-                <a:latin typeface="Arial"/>
+              <a:defRPr sz="4800" b="1">
+                <a:solidFill>
+                  <a:srgbClr val="FFFFFF"/>
+                </a:solidFill>
+                <a:latin typeface="Calibri"/>
               </a:defRPr>
             </a:pPr>
             <a:r>
-              <a:t>HACKERING 2.0 // REAL-TIME VOICE AI TRACK</a:t>
-            </a:r>
-          </a:p>
-        </p:txBody>
-      </p:sp>
-      <p:sp>
-        <p:nvSpPr>
-          <p:cNvPr id="4" name="TextBox 3"/>
+              <a:t>NeuroVocal AI</a:t>
+            </a:r>
+          </a:p>
+          <a:p>
+            <a:pPr>
+              <a:spcBef>
+                <a:spcPts val="800"/>
+              </a:spcBef>
+              <a:defRPr sz="2000">
+                <a:solidFill>
+                  <a:srgbClr val="38BDF8"/>
+                </a:solidFill>
+                <a:latin typeface="Calibri"/>
+              </a:defRPr>
+            </a:pPr>
+            <a:r>
+              <a:t>An Emergency Triage Voice System That Listens to the Physics of Your Vocal Cords</a:t>
+            </a:r>
+          </a:p>
+        </p:txBody>
+      </p:sp>
+      <p:sp>
+        <p:nvSpPr>
+          <p:cNvPr id="5" name="Rounded Rectangle 4"/>
+          <p:cNvSpPr/>
+          <p:nvPr/>
+        </p:nvSpPr>
+        <p:spPr>
+          <a:xfrm>
+            <a:off x="1097280" y="3840480"/>
+            <a:ext cx="9966960" cy="1463040"/>
+          </a:xfrm>
+          <a:prstGeom prst="roundRect">
+            <a:avLst/>
+          </a:prstGeom>
+          <a:solidFill>
+            <a:srgbClr val="1E293B"/>
+          </a:solidFill>
+          <a:ln>
+            <a:solidFill>
+              <a:srgbClr val="334155"/>
+            </a:solidFill>
+          </a:ln>
+        </p:spPr>
+        <p:style>
+          <a:lnRef idx="1">
+            <a:schemeClr val="accent1"/>
+          </a:lnRef>
+          <a:fillRef idx="3">
+            <a:schemeClr val="accent1"/>
+          </a:fillRef>
+          <a:effectRef idx="2">
+            <a:schemeClr val="accent1"/>
+          </a:effectRef>
+          <a:fontRef idx="minor">
+            <a:schemeClr val="lt1"/>
+          </a:fontRef>
+        </p:style>
+        <p:txBody>
+          <a:bodyPr rtlCol="0" anchor="ctr" wrap="square"/>
+          <a:lstStyle/>
+          <a:p>
+            <a:pPr algn="ctr">
+              <a:defRPr sz="1500" b="1">
+                <a:solidFill>
+                  <a:srgbClr val="FFFFFF"/>
+                </a:solidFill>
+                <a:latin typeface="Calibri"/>
+              </a:defRPr>
+            </a:pPr>
+            <a:r>
+              <a:t>Most voice bots only listen to the words callers say. NeuroVocal AI runs two processes at once:</a:t>
+            </a:r>
+          </a:p>
+          <a:p>
+            <a:pPr>
+              <a:spcBef>
+                <a:spcPts val="600"/>
+              </a:spcBef>
+              <a:defRPr sz="1400">
+                <a:solidFill>
+                  <a:srgbClr val="94A3B8"/>
+                </a:solidFill>
+                <a:latin typeface="Calibri"/>
+              </a:defRPr>
+            </a:pPr>
+            <a:r>
+              <a:t>1. An empathetic emergency operator that talks with the patient and coordinates location.</a:t>
+            </a:r>
+            <a:br/>
+            <a:r>
+              <a:t>2. A real-time digital signal processing (DSP) engine that scans raw microphone audio for vocal fold tremors, hypoxia, and acute stroke symptoms at 25 Hz.</a:t>
+            </a:r>
+          </a:p>
+        </p:txBody>
+      </p:sp>
+      <p:sp>
+        <p:nvSpPr>
+          <p:cNvPr id="6" name="TextBox 5"/>
           <p:cNvSpPr txBox="1"/>
           <p:nvPr/>
         </p:nvSpPr>
         <p:spPr>
           <a:xfrm>
-            <a:off x="731520" y="777240"/>
-            <a:ext cx="10698480" cy="640080"/>
+            <a:off x="1097280" y="5669280"/>
+            <a:ext cx="9966960" cy="457200"/>
           </a:xfrm>
           <a:prstGeom prst="rect">
             <a:avLst/>
@@ -3190,254 +3336,21 @@
           <a:noFill/>
         </p:spPr>
         <p:txBody>
-          <a:bodyPr wrap="square">
+          <a:bodyPr wrap="none">
             <a:spAutoFit/>
           </a:bodyPr>
           <a:lstStyle/>
           <a:p>
             <a:pPr>
-              <a:defRPr sz="2800" b="1">
-                <a:solidFill>
-                  <a:srgbClr val="F8FAFC"/>
-                </a:solidFill>
-                <a:latin typeface="Arial"/>
+              <a:defRPr sz="1300">
+                <a:solidFill>
+                  <a:srgbClr val="94A3B8"/>
+                </a:solidFill>
+                <a:latin typeface="Calibri"/>
               </a:defRPr>
             </a:pPr>
             <a:r>
-              <a:t>NeuroVocal AI</a:t>
-            </a:r>
-          </a:p>
-        </p:txBody>
-      </p:sp>
-      <p:sp>
-        <p:nvSpPr>
-          <p:cNvPr id="5" name="TextBox 4"/>
-          <p:cNvSpPr txBox="1"/>
-          <p:nvPr/>
-        </p:nvSpPr>
-        <p:spPr>
-          <a:xfrm>
-            <a:off x="731520" y="1371600"/>
-            <a:ext cx="10698480" cy="457200"/>
-          </a:xfrm>
-          <a:prstGeom prst="rect">
-            <a:avLst/>
-          </a:prstGeom>
-          <a:noFill/>
-        </p:spPr>
-        <p:txBody>
-          <a:bodyPr wrap="square">
-            <a:spAutoFit/>
-          </a:bodyPr>
-          <a:lstStyle/>
-          <a:p>
-            <a:pPr>
-              <a:defRPr sz="1400">
-                <a:solidFill>
-                  <a:srgbClr val="94A3B8"/>
-                </a:solidFill>
-                <a:latin typeface="Arial"/>
-              </a:defRPr>
-            </a:pPr>
-            <a:r>
-              <a:t>Dual-Stream Emergency Triage Voice System: Conversational Operator + Real-Time Acoustic Biomarker Engine</a:t>
-            </a:r>
-          </a:p>
-        </p:txBody>
-      </p:sp>
-      <p:sp>
-        <p:nvSpPr>
-          <p:cNvPr id="6" name="Rounded Rectangle 5"/>
-          <p:cNvSpPr/>
-          <p:nvPr/>
-        </p:nvSpPr>
-        <p:spPr>
-          <a:xfrm>
-            <a:off x="731520" y="1920240"/>
-            <a:ext cx="10728655" cy="3474720"/>
-          </a:xfrm>
-          <a:prstGeom prst="roundRect">
-            <a:avLst/>
-          </a:prstGeom>
-          <a:solidFill>
-            <a:srgbClr val="121826"/>
-          </a:solidFill>
-          <a:ln w="12700">
-            <a:solidFill>
-              <a:srgbClr val="1E293B"/>
-            </a:solidFill>
-          </a:ln>
-        </p:spPr>
-        <p:style>
-          <a:lnRef idx="1">
-            <a:schemeClr val="accent1"/>
-          </a:lnRef>
-          <a:fillRef idx="3">
-            <a:schemeClr val="accent1"/>
-          </a:fillRef>
-          <a:effectRef idx="2">
-            <a:schemeClr val="accent1"/>
-          </a:effectRef>
-          <a:fontRef idx="minor">
-            <a:schemeClr val="lt1"/>
-          </a:fontRef>
-        </p:style>
-        <p:txBody>
-          <a:bodyPr rtlCol="0" anchor="ctr"/>
-          <a:lstStyle/>
-          <a:p>
-            <a:pPr algn="ctr"/>
-          </a:p>
-        </p:txBody>
-      </p:sp>
-      <p:sp>
-        <p:nvSpPr>
-          <p:cNvPr id="7" name="TextBox 6"/>
-          <p:cNvSpPr txBox="1"/>
-          <p:nvPr/>
-        </p:nvSpPr>
-        <p:spPr>
-          <a:xfrm>
-            <a:off x="1005840" y="2103120"/>
-            <a:ext cx="10149840" cy="3108960"/>
-          </a:xfrm>
-          <a:prstGeom prst="rect">
-            <a:avLst/>
-          </a:prstGeom>
-          <a:noFill/>
-        </p:spPr>
-        <p:txBody>
-          <a:bodyPr wrap="square">
-            <a:spAutoFit/>
-          </a:bodyPr>
-          <a:lstStyle/>
-          <a:p>
-            <a:pPr>
-              <a:spcAft>
-                <a:spcPts val="1000"/>
-              </a:spcAft>
-              <a:defRPr sz="1500">
-                <a:solidFill>
-                  <a:srgbClr val="F8FAFC"/>
-                </a:solidFill>
-                <a:latin typeface="Arial"/>
-              </a:defRPr>
-            </a:pPr>
-            <a:r>
-              <a:t>Emergency caller audio analyzed simultaneously for words AND vocal tract biophysics</a:t>
-            </a:r>
-          </a:p>
-          <a:p>
-            <a:pPr>
-              <a:spcAft>
-                <a:spcPts val="1000"/>
-              </a:spcAft>
-              <a:defRPr sz="1500">
-                <a:solidFill>
-                  <a:srgbClr val="F8FAFC"/>
-                </a:solidFill>
-                <a:latin typeface="Arial"/>
-              </a:defRPr>
-            </a:pPr>
-            <a:r>
-              <a:t>Instant detection of acute stroke, dysarthria, and silent hypoxia from standard mic audio</a:t>
-            </a:r>
-          </a:p>
-          <a:p>
-            <a:pPr>
-              <a:spcAft>
-                <a:spcPts val="1000"/>
-              </a:spcAft>
-              <a:defRPr sz="1500">
-                <a:solidFill>
-                  <a:srgbClr val="F8FAFC"/>
-                </a:solidFill>
-                <a:latin typeface="Arial"/>
-              </a:defRPr>
-            </a:pPr>
-            <a:r>
-              <a:t>Sub-50ms digital signal processing (DSP) pipeline with 25 Hz live telemetry streaming</a:t>
-            </a:r>
-          </a:p>
-        </p:txBody>
-      </p:sp>
-      <p:sp>
-        <p:nvSpPr>
-          <p:cNvPr id="8" name="Rounded Rectangle 7"/>
-          <p:cNvSpPr/>
-          <p:nvPr/>
-        </p:nvSpPr>
-        <p:spPr>
-          <a:xfrm>
-            <a:off x="731520" y="5577840"/>
-            <a:ext cx="10728655" cy="731520"/>
-          </a:xfrm>
-          <a:prstGeom prst="roundRect">
-            <a:avLst/>
-          </a:prstGeom>
-          <a:solidFill>
-            <a:srgbClr val="0F172A"/>
-          </a:solidFill>
-          <a:ln w="12700">
-            <a:solidFill>
-              <a:srgbClr val="06B6D4"/>
-            </a:solidFill>
-          </a:ln>
-        </p:spPr>
-        <p:style>
-          <a:lnRef idx="1">
-            <a:schemeClr val="accent1"/>
-          </a:lnRef>
-          <a:fillRef idx="3">
-            <a:schemeClr val="accent1"/>
-          </a:fillRef>
-          <a:effectRef idx="2">
-            <a:schemeClr val="accent1"/>
-          </a:effectRef>
-          <a:fontRef idx="minor">
-            <a:schemeClr val="lt1"/>
-          </a:fontRef>
-        </p:style>
-        <p:txBody>
-          <a:bodyPr rtlCol="0" anchor="ctr"/>
-          <a:lstStyle/>
-          <a:p>
-            <a:pPr algn="ctr"/>
-          </a:p>
-        </p:txBody>
-      </p:sp>
-      <p:sp>
-        <p:nvSpPr>
-          <p:cNvPr id="9" name="TextBox 8"/>
-          <p:cNvSpPr txBox="1"/>
-          <p:nvPr/>
-        </p:nvSpPr>
-        <p:spPr>
-          <a:xfrm>
-            <a:off x="914400" y="5715000"/>
-            <a:ext cx="10332720" cy="457200"/>
-          </a:xfrm>
-          <a:prstGeom prst="rect">
-            <a:avLst/>
-          </a:prstGeom>
-          <a:noFill/>
-        </p:spPr>
-        <p:txBody>
-          <a:bodyPr wrap="square">
-            <a:spAutoFit/>
-          </a:bodyPr>
-          <a:lstStyle/>
-          <a:p>
-            <a:pPr>
-              <a:defRPr sz="1300" b="1">
-                <a:solidFill>
-                  <a:srgbClr val="06B6D4"/>
-                </a:solidFill>
-                <a:latin typeface="Arial"/>
-              </a:defRPr>
-            </a:pPr>
-            <a:r>
-              <a:t>⚡  NOT JUST A CHATBOT: Audio Physics + Voice AI for Emergency Dispatch</a:t>
+              <a:t>Built by Harish &amp; Team  |  RV College of Engineering  |  Round 1 Project Pitch</a:t>
             </a:r>
           </a:p>
         </p:txBody>
@@ -3475,7 +3388,7 @@
             <a:avLst/>
           </a:prstGeom>
           <a:solidFill>
-            <a:srgbClr val="090D16"/>
+            <a:srgbClr val="0F172A"/>
           </a:solidFill>
           <a:ln>
             <a:noFill/>
@@ -3511,8 +3424,8 @@
         </p:nvSpPr>
         <p:spPr>
           <a:xfrm>
-            <a:off x="731520" y="457200"/>
-            <a:ext cx="10698480" cy="365760"/>
+            <a:off x="914400" y="548640"/>
+            <a:ext cx="10332720" cy="914400"/>
           </a:xfrm>
           <a:prstGeom prst="rect">
             <a:avLst/>
@@ -3520,117 +3433,58 @@
           <a:noFill/>
         </p:spPr>
         <p:txBody>
-          <a:bodyPr wrap="square">
+          <a:bodyPr wrap="none">
             <a:spAutoFit/>
           </a:bodyPr>
           <a:lstStyle/>
           <a:p>
             <a:pPr>
-              <a:defRPr sz="1100" b="1">
-                <a:solidFill>
-                  <a:srgbClr val="06B6D4"/>
-                </a:solidFill>
-                <a:latin typeface="Arial"/>
+              <a:defRPr sz="2800" b="1">
+                <a:solidFill>
+                  <a:srgbClr val="FFFFFF"/>
+                </a:solidFill>
+                <a:latin typeface="Calibri"/>
               </a:defRPr>
             </a:pPr>
             <a:r>
-              <a:t>THE EMERGENCY CRISIS</a:t>
-            </a:r>
-          </a:p>
-        </p:txBody>
-      </p:sp>
-      <p:sp>
-        <p:nvSpPr>
-          <p:cNvPr id="4" name="TextBox 3"/>
-          <p:cNvSpPr txBox="1"/>
+              <a:t>The Problem in Real Emergency Calls: When Words Lie</a:t>
+            </a:r>
+          </a:p>
+          <a:p>
+            <a:pPr>
+              <a:defRPr sz="1400">
+                <a:solidFill>
+                  <a:srgbClr val="94A3B8"/>
+                </a:solidFill>
+                <a:latin typeface="Calibri"/>
+              </a:defRPr>
+            </a:pPr>
+            <a:r>
+              <a:t>Why standard AI voice assistants fail when human callers are having an acute medical crisis.</a:t>
+            </a:r>
+          </a:p>
+        </p:txBody>
+      </p:sp>
+      <p:sp>
+        <p:nvSpPr>
+          <p:cNvPr id="4" name="Rounded Rectangle 3"/>
+          <p:cNvSpPr/>
           <p:nvPr/>
         </p:nvSpPr>
         <p:spPr>
           <a:xfrm>
-            <a:off x="731520" y="777240"/>
-            <a:ext cx="10698480" cy="640080"/>
-          </a:xfrm>
-          <a:prstGeom prst="rect">
-            <a:avLst/>
-          </a:prstGeom>
-          <a:noFill/>
-        </p:spPr>
-        <p:txBody>
-          <a:bodyPr wrap="square">
-            <a:spAutoFit/>
-          </a:bodyPr>
-          <a:lstStyle/>
-          <a:p>
-            <a:pPr>
-              <a:defRPr sz="2800" b="1">
-                <a:solidFill>
-                  <a:srgbClr val="F8FAFC"/>
-                </a:solidFill>
-                <a:latin typeface="Arial"/>
-              </a:defRPr>
-            </a:pPr>
-            <a:r>
-              <a:t>When Seconds Count, Words Fail</a:t>
-            </a:r>
-          </a:p>
-        </p:txBody>
-      </p:sp>
-      <p:sp>
-        <p:nvSpPr>
-          <p:cNvPr id="5" name="TextBox 4"/>
-          <p:cNvSpPr txBox="1"/>
-          <p:nvPr/>
-        </p:nvSpPr>
-        <p:spPr>
-          <a:xfrm>
-            <a:off x="731520" y="1371600"/>
-            <a:ext cx="10698480" cy="457200"/>
-          </a:xfrm>
-          <a:prstGeom prst="rect">
-            <a:avLst/>
-          </a:prstGeom>
-          <a:noFill/>
-        </p:spPr>
-        <p:txBody>
-          <a:bodyPr wrap="square">
-            <a:spAutoFit/>
-          </a:bodyPr>
-          <a:lstStyle/>
-          <a:p>
-            <a:pPr>
-              <a:defRPr sz="1400">
-                <a:solidFill>
-                  <a:srgbClr val="94A3B8"/>
-                </a:solidFill>
-                <a:latin typeface="Arial"/>
-              </a:defRPr>
-            </a:pPr>
-            <a:r>
-              <a:t>Traditional conversational triage relies entirely on caller articulation</a:t>
-            </a:r>
-          </a:p>
-        </p:txBody>
-      </p:sp>
-      <p:sp>
-        <p:nvSpPr>
-          <p:cNvPr id="6" name="Rounded Rectangle 5"/>
-          <p:cNvSpPr/>
-          <p:nvPr/>
-        </p:nvSpPr>
-        <p:spPr>
-          <a:xfrm>
-            <a:off x="731520" y="1920240"/>
-            <a:ext cx="10728655" cy="3474720"/>
+            <a:off x="914400" y="1645920"/>
+            <a:ext cx="4937760" cy="4389120"/>
           </a:xfrm>
           <a:prstGeom prst="roundRect">
             <a:avLst/>
           </a:prstGeom>
           <a:solidFill>
-            <a:srgbClr val="121826"/>
+            <a:srgbClr val="1E293B"/>
           </a:solidFill>
-          <a:ln w="12700">
+          <a:ln>
             <a:solidFill>
-              <a:srgbClr val="1E293B"/>
+              <a:srgbClr val="334155"/>
             </a:solidFill>
           </a:ln>
         </p:spPr>
@@ -3649,120 +3503,73 @@
           </a:fontRef>
         </p:style>
         <p:txBody>
-          <a:bodyPr rtlCol="0" anchor="ctr"/>
-          <a:lstStyle/>
-          <a:p>
-            <a:pPr algn="ctr"/>
-          </a:p>
-        </p:txBody>
-      </p:sp>
-      <p:sp>
-        <p:nvSpPr>
-          <p:cNvPr id="7" name="TextBox 6"/>
-          <p:cNvSpPr txBox="1"/>
+          <a:bodyPr rtlCol="0" anchor="ctr" wrap="square"/>
+          <a:lstStyle/>
+          <a:p>
+            <a:pPr algn="ctr">
+              <a:defRPr sz="1500" b="1">
+                <a:solidFill>
+                  <a:srgbClr val="FB7185"/>
+                </a:solidFill>
+                <a:latin typeface="Calibri"/>
+              </a:defRPr>
+            </a:pPr>
+            <a:r>
+              <a:t>WHAT STANDARD VOICE BOTS DO</a:t>
+            </a:r>
+          </a:p>
+          <a:p>
+            <a:br/>
+            <a:pPr>
+              <a:defRPr sz="1400">
+                <a:solidFill>
+                  <a:srgbClr val="94A3B8"/>
+                </a:solidFill>
+                <a:latin typeface="Calibri"/>
+              </a:defRPr>
+            </a:pPr>
+            <a:r>
+              <a:t>• Listens only to transcribed words (Speech-to-Text).</a:t>
+            </a:r>
+            <a:br/>
+            <a:r>
+              <a:t>• When a patient says: 'I just feel a bit tired and lightheaded today',</a:t>
+            </a:r>
+            <a:br/>
+            <a:r>
+              <a:t>the bot assumes mild exhaustion.</a:t>
+            </a:r>
+            <a:br/>
+            <a:r>
+              <a:t>• Recommends resting, drinking water, or booking a routine clinic visit.</a:t>
+            </a:r>
+            <a:br/>
+            <a:r>
+              <a:t>• By the time an ambulance is called, the 4.5-hour stroke treatment window has closed.</a:t>
+            </a:r>
+          </a:p>
+        </p:txBody>
+      </p:sp>
+      <p:sp>
+        <p:nvSpPr>
+          <p:cNvPr id="5" name="Rounded Rectangle 4"/>
+          <p:cNvSpPr/>
           <p:nvPr/>
         </p:nvSpPr>
         <p:spPr>
           <a:xfrm>
-            <a:off x="1005840" y="2103120"/>
-            <a:ext cx="10149840" cy="3108960"/>
-          </a:xfrm>
-          <a:prstGeom prst="rect">
-            <a:avLst/>
-          </a:prstGeom>
-          <a:noFill/>
-        </p:spPr>
-        <p:txBody>
-          <a:bodyPr wrap="square">
-            <a:spAutoFit/>
-          </a:bodyPr>
-          <a:lstStyle/>
-          <a:p>
-            <a:pPr>
-              <a:spcAft>
-                <a:spcPts val="1000"/>
-              </a:spcAft>
-              <a:defRPr sz="1500">
-                <a:solidFill>
-                  <a:srgbClr val="F8FAFC"/>
-                </a:solidFill>
-                <a:latin typeface="Arial"/>
-              </a:defRPr>
-            </a:pPr>
-            <a:r>
-              <a:t>Panicked or confused callers often under-report or misdescribe acute neurological symptoms</a:t>
-            </a:r>
-          </a:p>
-          <a:p>
-            <a:pPr>
-              <a:spcAft>
-                <a:spcPts val="1000"/>
-              </a:spcAft>
-              <a:defRPr sz="1500">
-                <a:solidFill>
-                  <a:srgbClr val="F8FAFC"/>
-                </a:solidFill>
-                <a:latin typeface="Arial"/>
-              </a:defRPr>
-            </a:pPr>
-            <a:r>
-              <a:t>An elderly stroke patient may casually say 'I feel a bit tired today' while their facial muscles droop</a:t>
-            </a:r>
-          </a:p>
-          <a:p>
-            <a:pPr>
-              <a:spcAft>
-                <a:spcPts val="1000"/>
-              </a:spcAft>
-              <a:defRPr sz="1500">
-                <a:solidFill>
-                  <a:srgbClr val="F8FAFC"/>
-                </a:solidFill>
-                <a:latin typeface="Arial"/>
-              </a:defRPr>
-            </a:pPr>
-            <a:r>
-              <a:t>Standard LLM voice agents interpret the text literally and classify the call as low-urgency</a:t>
-            </a:r>
-          </a:p>
-          <a:p>
-            <a:pPr>
-              <a:spcAft>
-                <a:spcPts val="1000"/>
-              </a:spcAft>
-              <a:defRPr sz="1500">
-                <a:solidFill>
-                  <a:srgbClr val="F8FAFC"/>
-                </a:solidFill>
-                <a:latin typeface="Arial"/>
-              </a:defRPr>
-            </a:pPr>
-            <a:r>
-              <a:t>Delayed ambulance dispatch leads to permanent brain damage or preventable mortality</a:t>
-            </a:r>
-          </a:p>
-        </p:txBody>
-      </p:sp>
-      <p:sp>
-        <p:nvSpPr>
-          <p:cNvPr id="8" name="Rounded Rectangle 7"/>
-          <p:cNvSpPr/>
-          <p:nvPr/>
-        </p:nvSpPr>
-        <p:spPr>
-          <a:xfrm>
-            <a:off x="731520" y="5577840"/>
-            <a:ext cx="10728655" cy="731520"/>
+            <a:off x="6309360" y="1645920"/>
+            <a:ext cx="4937760" cy="4389120"/>
           </a:xfrm>
           <a:prstGeom prst="roundRect">
             <a:avLst/>
           </a:prstGeom>
           <a:solidFill>
-            <a:srgbClr val="0F172A"/>
+            <a:srgbClr val="1E293B"/>
           </a:solidFill>
           <a:ln w="12700">
             <a:solidFill>
-              <a:srgbClr val="06B6D4"/>
+              <a:srgbClr val="38BDF8"/>
             </a:solidFill>
           </a:ln>
         </p:spPr>
@@ -3781,45 +3588,49 @@
           </a:fontRef>
         </p:style>
         <p:txBody>
-          <a:bodyPr rtlCol="0" anchor="ctr"/>
-          <a:lstStyle/>
-          <a:p>
-            <a:pPr algn="ctr"/>
-          </a:p>
-        </p:txBody>
-      </p:sp>
-      <p:sp>
-        <p:nvSpPr>
-          <p:cNvPr id="9" name="TextBox 8"/>
-          <p:cNvSpPr txBox="1"/>
-          <p:nvPr/>
-        </p:nvSpPr>
-        <p:spPr>
-          <a:xfrm>
-            <a:off x="914400" y="5715000"/>
-            <a:ext cx="10332720" cy="457200"/>
-          </a:xfrm>
-          <a:prstGeom prst="rect">
-            <a:avLst/>
-          </a:prstGeom>
-          <a:noFill/>
-        </p:spPr>
-        <p:txBody>
-          <a:bodyPr wrap="square">
-            <a:spAutoFit/>
-          </a:bodyPr>
-          <a:lstStyle/>
-          <a:p>
+          <a:bodyPr rtlCol="0" anchor="ctr" wrap="square"/>
+          <a:lstStyle/>
+          <a:p>
+            <a:pPr algn="ctr">
+              <a:defRPr sz="1500" b="1">
+                <a:solidFill>
+                  <a:srgbClr val="38BDF8"/>
+                </a:solidFill>
+                <a:latin typeface="Calibri"/>
+              </a:defRPr>
+            </a:pPr>
+            <a:r>
+              <a:t>WHAT NEUROVOCAL AI HEARS</a:t>
+            </a:r>
+          </a:p>
+          <a:p>
+            <a:br/>
             <a:pPr>
-              <a:defRPr sz="1300" b="1">
-                <a:solidFill>
-                  <a:srgbClr val="06B6D4"/>
-                </a:solidFill>
-                <a:latin typeface="Arial"/>
+              <a:defRPr sz="1400">
+                <a:solidFill>
+                  <a:srgbClr val="FFFFFF"/>
+                </a:solidFill>
+                <a:latin typeface="Calibri"/>
               </a:defRPr>
             </a:pPr>
             <a:r>
-              <a:t>⚡  80% of preventable triage delays stem from caller inability to verbalize symptoms accurately.</a:t>
+              <a:t>• Inspects the raw audio physics behind their voice.</a:t>
+            </a:r>
+            <a:br/>
+            <a:r>
+              <a:t>• The caller may sound calm, but facial paralysis causes unilateral vocal tract asymmetry.</a:t>
+            </a:r>
+            <a:br/>
+            <a:r>
+              <a:t>• Formants F1 and F2 collapse into 1500 Hz (dysarthric vowel slur).</a:t>
+            </a:r>
+            <a:br/>
+            <a:r>
+              <a:t>• Jitter spikes above 2.5% due to vocal fold tremors.</a:t>
+            </a:r>
+            <a:br/>
+            <a:r>
+              <a:t>• Instantly alerts the dispatcher: 'CODE RED: SUSPECTED STROKE'.</a:t>
             </a:r>
           </a:p>
         </p:txBody>
@@ -3857,7 +3668,7 @@
             <a:avLst/>
           </a:prstGeom>
           <a:solidFill>
-            <a:srgbClr val="090D16"/>
+            <a:srgbClr val="0F172A"/>
           </a:solidFill>
           <a:ln>
             <a:noFill/>
@@ -3893,8 +3704,8 @@
         </p:nvSpPr>
         <p:spPr>
           <a:xfrm>
-            <a:off x="731520" y="457200"/>
-            <a:ext cx="10698480" cy="365760"/>
+            <a:off x="914400" y="548640"/>
+            <a:ext cx="10332720" cy="914400"/>
           </a:xfrm>
           <a:prstGeom prst="rect">
             <a:avLst/>
@@ -3902,117 +3713,58 @@
           <a:noFill/>
         </p:spPr>
         <p:txBody>
-          <a:bodyPr wrap="square">
+          <a:bodyPr wrap="none">
             <a:spAutoFit/>
           </a:bodyPr>
           <a:lstStyle/>
           <a:p>
             <a:pPr>
-              <a:defRPr sz="1100" b="1">
-                <a:solidFill>
-                  <a:srgbClr val="06B6D4"/>
-                </a:solidFill>
-                <a:latin typeface="Arial"/>
+              <a:defRPr sz="2800" b="1">
+                <a:solidFill>
+                  <a:srgbClr val="FFFFFF"/>
+                </a:solidFill>
+                <a:latin typeface="Calibri"/>
               </a:defRPr>
             </a:pPr>
             <a:r>
-              <a:t>THE CORE INNOVATION</a:t>
-            </a:r>
-          </a:p>
-        </p:txBody>
-      </p:sp>
-      <p:sp>
-        <p:nvSpPr>
-          <p:cNvPr id="4" name="TextBox 3"/>
-          <p:cNvSpPr txBox="1"/>
+              <a:t>The Solution: Dual-Stream Real-Time Architecture</a:t>
+            </a:r>
+          </a:p>
+          <a:p>
+            <a:pPr>
+              <a:defRPr sz="1400">
+                <a:solidFill>
+                  <a:srgbClr val="94A3B8"/>
+                </a:solidFill>
+                <a:latin typeface="Calibri"/>
+              </a:defRPr>
+            </a:pPr>
+            <a:r>
+              <a:t>Two dedicated tasks running in parallel over the exact same microphone audio stream.</a:t>
+            </a:r>
+          </a:p>
+        </p:txBody>
+      </p:sp>
+      <p:sp>
+        <p:nvSpPr>
+          <p:cNvPr id="4" name="Rounded Rectangle 3"/>
+          <p:cNvSpPr/>
           <p:nvPr/>
         </p:nvSpPr>
         <p:spPr>
           <a:xfrm>
-            <a:off x="731520" y="777240"/>
-            <a:ext cx="10698480" cy="640080"/>
-          </a:xfrm>
-          <a:prstGeom prst="rect">
-            <a:avLst/>
-          </a:prstGeom>
-          <a:noFill/>
-        </p:spPr>
-        <p:txBody>
-          <a:bodyPr wrap="square">
-            <a:spAutoFit/>
-          </a:bodyPr>
-          <a:lstStyle/>
-          <a:p>
-            <a:pPr>
-              <a:defRPr sz="2800" b="1">
-                <a:solidFill>
-                  <a:srgbClr val="F8FAFC"/>
-                </a:solidFill>
-                <a:latin typeface="Arial"/>
-              </a:defRPr>
-            </a:pPr>
-            <a:r>
-              <a:t>Dual-Stream Architecture</a:t>
-            </a:r>
-          </a:p>
-        </p:txBody>
-      </p:sp>
-      <p:sp>
-        <p:nvSpPr>
-          <p:cNvPr id="5" name="TextBox 4"/>
-          <p:cNvSpPr txBox="1"/>
-          <p:nvPr/>
-        </p:nvSpPr>
-        <p:spPr>
-          <a:xfrm>
-            <a:off x="731520" y="1371600"/>
-            <a:ext cx="10698480" cy="457200"/>
-          </a:xfrm>
-          <a:prstGeom prst="rect">
-            <a:avLst/>
-          </a:prstGeom>
-          <a:noFill/>
-        </p:spPr>
-        <p:txBody>
-          <a:bodyPr wrap="square">
-            <a:spAutoFit/>
-          </a:bodyPr>
-          <a:lstStyle/>
-          <a:p>
-            <a:pPr>
-              <a:defRPr sz="1400">
-                <a:solidFill>
-                  <a:srgbClr val="94A3B8"/>
-                </a:solidFill>
-                <a:latin typeface="Arial"/>
-              </a:defRPr>
-            </a:pPr>
-            <a:r>
-              <a:t>Conversational empathy in parallel with raw audio biophysical inspection</a:t>
-            </a:r>
-          </a:p>
-        </p:txBody>
-      </p:sp>
-      <p:sp>
-        <p:nvSpPr>
-          <p:cNvPr id="6" name="Rounded Rectangle 5"/>
-          <p:cNvSpPr/>
-          <p:nvPr/>
-        </p:nvSpPr>
-        <p:spPr>
-          <a:xfrm>
-            <a:off x="731520" y="1920240"/>
-            <a:ext cx="10728655" cy="3474720"/>
+            <a:off x="914400" y="1645920"/>
+            <a:ext cx="4937760" cy="3840480"/>
           </a:xfrm>
           <a:prstGeom prst="roundRect">
             <a:avLst/>
           </a:prstGeom>
           <a:solidFill>
-            <a:srgbClr val="121826"/>
+            <a:srgbClr val="1E293B"/>
           </a:solidFill>
-          <a:ln w="12700">
+          <a:ln>
             <a:solidFill>
-              <a:srgbClr val="1E293B"/>
+              <a:srgbClr val="334155"/>
             </a:solidFill>
           </a:ln>
         </p:spPr>
@@ -4031,126 +3783,140 @@
           </a:fontRef>
         </p:style>
         <p:txBody>
-          <a:bodyPr rtlCol="0" anchor="ctr"/>
-          <a:lstStyle/>
-          <a:p>
-            <a:pPr algn="ctr"/>
-          </a:p>
-        </p:txBody>
-      </p:sp>
-      <p:sp>
-        <p:nvSpPr>
-          <p:cNvPr id="7" name="TextBox 6"/>
-          <p:cNvSpPr txBox="1"/>
+          <a:bodyPr rtlCol="0" anchor="ctr" wrap="square"/>
+          <a:lstStyle/>
+          <a:p>
+            <a:pPr algn="ctr">
+              <a:defRPr sz="1600" b="1">
+                <a:solidFill>
+                  <a:srgbClr val="34D399"/>
+                </a:solidFill>
+                <a:latin typeface="Calibri"/>
+              </a:defRPr>
+            </a:pPr>
+            <a:r>
+              <a:t>STREAM 1: The Conversational Operator</a:t>
+            </a:r>
+          </a:p>
+          <a:p>
+            <a:br/>
+            <a:pPr>
+              <a:defRPr sz="1400">
+                <a:solidFill>
+                  <a:srgbClr val="94A3B8"/>
+                </a:solidFill>
+                <a:latin typeface="Calibri"/>
+              </a:defRPr>
+            </a:pPr>
+            <a:r>
+              <a:t>• Deepgram Nova-2: Real-time speech transcription (&lt; 250ms).</a:t>
+            </a:r>
+            <a:br/>
+            <a:r>
+              <a:t>• Groq Llama 3.3 70B: Fast clinical triage logic. Keeps answers under 25 words to avoid panicking the caller.</a:t>
+            </a:r>
+            <a:br/>
+            <a:r>
+              <a:t>• Cartesia Sonic: Empathetic, human-like voice synthesis (&lt; 150ms).</a:t>
+            </a:r>
+            <a:br/>
+            <a:r>
+              <a:t>• Goal: Asks for location, confirms patient posture, keeps them calm.</a:t>
+            </a:r>
+          </a:p>
+        </p:txBody>
+      </p:sp>
+      <p:sp>
+        <p:nvSpPr>
+          <p:cNvPr id="5" name="Rounded Rectangle 4"/>
+          <p:cNvSpPr/>
           <p:nvPr/>
         </p:nvSpPr>
         <p:spPr>
           <a:xfrm>
-            <a:off x="1005840" y="2103120"/>
-            <a:ext cx="10149840" cy="3108960"/>
+            <a:off x="6309360" y="1645920"/>
+            <a:ext cx="4937760" cy="3840480"/>
           </a:xfrm>
-          <a:prstGeom prst="rect">
+          <a:prstGeom prst="roundRect">
             <a:avLst/>
           </a:prstGeom>
-          <a:noFill/>
+          <a:solidFill>
+            <a:srgbClr val="1E293B"/>
+          </a:solidFill>
+          <a:ln w="12700">
+            <a:solidFill>
+              <a:srgbClr val="38BDF8"/>
+            </a:solidFill>
+          </a:ln>
         </p:spPr>
-        <p:txBody>
-          <a:bodyPr wrap="square">
-            <a:spAutoFit/>
-          </a:bodyPr>
-          <a:lstStyle/>
-          <a:p>
+        <p:style>
+          <a:lnRef idx="1">
+            <a:schemeClr val="accent1"/>
+          </a:lnRef>
+          <a:fillRef idx="3">
+            <a:schemeClr val="accent1"/>
+          </a:fillRef>
+          <a:effectRef idx="2">
+            <a:schemeClr val="accent1"/>
+          </a:effectRef>
+          <a:fontRef idx="minor">
+            <a:schemeClr val="lt1"/>
+          </a:fontRef>
+        </p:style>
+        <p:txBody>
+          <a:bodyPr rtlCol="0" anchor="ctr" wrap="square"/>
+          <a:lstStyle/>
+          <a:p>
+            <a:pPr algn="ctr">
+              <a:defRPr sz="1600" b="1">
+                <a:solidFill>
+                  <a:srgbClr val="38BDF8"/>
+                </a:solidFill>
+                <a:latin typeface="Calibri"/>
+              </a:defRPr>
+            </a:pPr>
+            <a:r>
+              <a:t>STREAM 2: The Acoustic Health Scanner</a:t>
+            </a:r>
+          </a:p>
+          <a:p>
+            <a:br/>
             <a:pPr>
-              <a:spcAft>
-                <a:spcPts val="1000"/>
-              </a:spcAft>
-              <a:defRPr sz="1500">
-                <a:solidFill>
-                  <a:srgbClr val="F8FAFC"/>
-                </a:solidFill>
-                <a:latin typeface="Arial"/>
+              <a:defRPr sz="1400">
+                <a:solidFill>
+                  <a:srgbClr val="FFFFFF"/>
+                </a:solidFill>
+                <a:latin typeface="Calibri"/>
               </a:defRPr>
             </a:pPr>
             <a:r>
-              <a:t>STREAM 1: Conversational Loop (Deepgram Nova-2 + Groq Llama 3.3 + Cartesia TTS)</a:t>
-            </a:r>
-          </a:p>
-          <a:p>
-            <a:pPr>
-              <a:spcAft>
-                <a:spcPts val="1000"/>
-              </a:spcAft>
-              <a:defRPr sz="1500">
-                <a:solidFill>
-                  <a:srgbClr val="F8FAFC"/>
-                </a:solidFill>
-                <a:latin typeface="Arial"/>
-              </a:defRPr>
-            </a:pPr>
-            <a:r>
-              <a:t>  • Speaks calmly to the patient, asks critical safety questions, collects address and context.</a:t>
-            </a:r>
-          </a:p>
-          <a:p>
-            <a:pPr>
-              <a:spcAft>
-                <a:spcPts val="1000"/>
-              </a:spcAft>
-              <a:defRPr sz="1500">
-                <a:solidFill>
-                  <a:srgbClr val="F8FAFC"/>
-                </a:solidFill>
-                <a:latin typeface="Arial"/>
-              </a:defRPr>
-            </a:pPr>
-            <a:r>
-              <a:t>STREAM 2: Hidden Health Scanner (neurovocal_poc.py DSP Audio Engine)</a:t>
-            </a:r>
-          </a:p>
-          <a:p>
-            <a:pPr>
-              <a:spcAft>
-                <a:spcPts val="1000"/>
-              </a:spcAft>
-              <a:defRPr sz="1500">
-                <a:solidFill>
-                  <a:srgbClr val="F8FAFC"/>
-                </a:solidFill>
-                <a:latin typeface="Arial"/>
-              </a:defRPr>
-            </a:pPr>
-            <a:r>
-              <a:t>  • Taps the raw PCM audio buffer in real time without interfering with speech latency.</a:t>
-            </a:r>
-          </a:p>
-          <a:p>
-            <a:pPr>
-              <a:spcAft>
-                <a:spcPts val="1000"/>
-              </a:spcAft>
-              <a:defRPr sz="1500">
-                <a:solidFill>
-                  <a:srgbClr val="F8FAFC"/>
-                </a:solidFill>
-                <a:latin typeface="Arial"/>
-              </a:defRPr>
-            </a:pPr>
-            <a:r>
-              <a:t>  • Extracts micro-perturbations, resonant frequencies, and airway turbulence at 25 Hz.</a:t>
-            </a:r>
-          </a:p>
-        </p:txBody>
-      </p:sp>
-      <p:sp>
-        <p:nvSpPr>
-          <p:cNvPr id="8" name="Rounded Rectangle 7"/>
+              <a:t>• 16 kHz Circular Ring Buffer: Captures audio frames in memory.</a:t>
+            </a:r>
+            <a:br/>
+            <a:r>
+              <a:t>• 25 Hz DSP Engine: Slides a 64 ms analysis window every 40 ms.</a:t>
+            </a:r>
+            <a:br/>
+            <a:r>
+              <a:t>• Mathematical Extraction: Calculates F0 pitch, jitter, HNR, and LPC formants without LLM overhead.</a:t>
+            </a:r>
+            <a:br/>
+            <a:r>
+              <a:t>• WebSocket Broadcast: Sends live JSON telemetry to dispatcher HUD.</a:t>
+            </a:r>
+          </a:p>
+        </p:txBody>
+      </p:sp>
+      <p:sp>
+        <p:nvSpPr>
+          <p:cNvPr id="6" name="Rounded Rectangle 5"/>
           <p:cNvSpPr/>
           <p:nvPr/>
         </p:nvSpPr>
         <p:spPr>
           <a:xfrm>
-            <a:off x="731520" y="5577840"/>
-            <a:ext cx="10728655" cy="731520"/>
+            <a:off x="914400" y="5669280"/>
+            <a:ext cx="10332720" cy="731520"/>
           </a:xfrm>
           <a:prstGeom prst="roundRect">
             <a:avLst/>
@@ -4158,9 +3924,9 @@
           <a:solidFill>
             <a:srgbClr val="0F172A"/>
           </a:solidFill>
-          <a:ln w="12700">
+          <a:ln>
             <a:solidFill>
-              <a:srgbClr val="06B6D4"/>
+              <a:srgbClr val="334155"/>
             </a:solidFill>
           </a:ln>
         </p:spPr>
@@ -4182,42 +3948,16 @@
           <a:bodyPr rtlCol="0" anchor="ctr"/>
           <a:lstStyle/>
           <a:p>
-            <a:pPr algn="ctr"/>
-          </a:p>
-        </p:txBody>
-      </p:sp>
-      <p:sp>
-        <p:nvSpPr>
-          <p:cNvPr id="9" name="TextBox 8"/>
-          <p:cNvSpPr txBox="1"/>
-          <p:nvPr/>
-        </p:nvSpPr>
-        <p:spPr>
-          <a:xfrm>
-            <a:off x="914400" y="5715000"/>
-            <a:ext cx="10332720" cy="457200"/>
-          </a:xfrm>
-          <a:prstGeom prst="rect">
-            <a:avLst/>
-          </a:prstGeom>
-          <a:noFill/>
-        </p:spPr>
-        <p:txBody>
-          <a:bodyPr wrap="square">
-            <a:spAutoFit/>
-          </a:bodyPr>
-          <a:lstStyle/>
-          <a:p>
-            <a:pPr>
+            <a:pPr algn="ctr">
               <a:defRPr sz="1300" b="1">
                 <a:solidFill>
-                  <a:srgbClr val="06B6D4"/>
-                </a:solidFill>
-                <a:latin typeface="Arial"/>
+                  <a:srgbClr val="34D399"/>
+                </a:solidFill>
+                <a:latin typeface="Calibri"/>
               </a:defRPr>
             </a:pPr>
             <a:r>
-              <a:t>⚡  The digital stethoscope for emergency telephony: listening to HOW you speak, not just what you say.</a:t>
+              <a:t>Key Engineering Principle: The DSP scanner runs asynchronously. The conversational bot never stutters, and the medical telemetry never lags.</a:t>
             </a:r>
           </a:p>
         </p:txBody>
@@ -4255,7 +3995,7 @@
             <a:avLst/>
           </a:prstGeom>
           <a:solidFill>
-            <a:srgbClr val="090D16"/>
+            <a:srgbClr val="0F172A"/>
           </a:solidFill>
           <a:ln>
             <a:noFill/>
@@ -4291,8 +4031,8 @@
         </p:nvSpPr>
         <p:spPr>
           <a:xfrm>
-            <a:off x="731520" y="457200"/>
-            <a:ext cx="10698480" cy="365760"/>
+            <a:off x="914400" y="548640"/>
+            <a:ext cx="10332720" cy="914400"/>
           </a:xfrm>
           <a:prstGeom prst="rect">
             <a:avLst/>
@@ -4300,117 +4040,58 @@
           <a:noFill/>
         </p:spPr>
         <p:txBody>
-          <a:bodyPr wrap="square">
+          <a:bodyPr wrap="none">
             <a:spAutoFit/>
           </a:bodyPr>
           <a:lstStyle/>
           <a:p>
             <a:pPr>
-              <a:defRPr sz="1100" b="1">
-                <a:solidFill>
-                  <a:srgbClr val="06B6D4"/>
-                </a:solidFill>
-                <a:latin typeface="Arial"/>
+              <a:defRPr sz="2800" b="1">
+                <a:solidFill>
+                  <a:srgbClr val="FFFFFF"/>
+                </a:solidFill>
+                <a:latin typeface="Calibri"/>
               </a:defRPr>
             </a:pPr>
             <a:r>
-              <a:t>ACOUSTIC BIOMARKERS</a:t>
-            </a:r>
-          </a:p>
-        </p:txBody>
-      </p:sp>
-      <p:sp>
-        <p:nvSpPr>
-          <p:cNvPr id="4" name="TextBox 3"/>
-          <p:cNvSpPr txBox="1"/>
+              <a:t>The Audio Physics: What We Listen For</a:t>
+            </a:r>
+          </a:p>
+          <a:p>
+            <a:pPr>
+              <a:defRPr sz="1400">
+                <a:solidFill>
+                  <a:srgbClr val="94A3B8"/>
+                </a:solidFill>
+                <a:latin typeface="Calibri"/>
+              </a:defRPr>
+            </a:pPr>
+            <a:r>
+              <a:t>Four clinical biomarkers extracted in real time from live speech signals.</a:t>
+            </a:r>
+          </a:p>
+        </p:txBody>
+      </p:sp>
+      <p:sp>
+        <p:nvSpPr>
+          <p:cNvPr id="4" name="Rounded Rectangle 3"/>
+          <p:cNvSpPr/>
           <p:nvPr/>
         </p:nvSpPr>
         <p:spPr>
           <a:xfrm>
-            <a:off x="731520" y="777240"/>
-            <a:ext cx="10698480" cy="640080"/>
-          </a:xfrm>
-          <a:prstGeom prst="rect">
-            <a:avLst/>
-          </a:prstGeom>
-          <a:noFill/>
-        </p:spPr>
-        <p:txBody>
-          <a:bodyPr wrap="square">
-            <a:spAutoFit/>
-          </a:bodyPr>
-          <a:lstStyle/>
-          <a:p>
-            <a:pPr>
-              <a:defRPr sz="2800" b="1">
-                <a:solidFill>
-                  <a:srgbClr val="F8FAFC"/>
-                </a:solidFill>
-                <a:latin typeface="Arial"/>
-              </a:defRPr>
-            </a:pPr>
-            <a:r>
-              <a:t>The Physics of Vocal Distress</a:t>
-            </a:r>
-          </a:p>
-        </p:txBody>
-      </p:sp>
-      <p:sp>
-        <p:nvSpPr>
-          <p:cNvPr id="5" name="TextBox 4"/>
-          <p:cNvSpPr txBox="1"/>
-          <p:nvPr/>
-        </p:nvSpPr>
-        <p:spPr>
-          <a:xfrm>
-            <a:off x="731520" y="1371600"/>
-            <a:ext cx="10698480" cy="457200"/>
-          </a:xfrm>
-          <a:prstGeom prst="rect">
-            <a:avLst/>
-          </a:prstGeom>
-          <a:noFill/>
-        </p:spPr>
-        <p:txBody>
-          <a:bodyPr wrap="square">
-            <a:spAutoFit/>
-          </a:bodyPr>
-          <a:lstStyle/>
-          <a:p>
-            <a:pPr>
-              <a:defRPr sz="1400">
-                <a:solidFill>
-                  <a:srgbClr val="94A3B8"/>
-                </a:solidFill>
-                <a:latin typeface="Arial"/>
-              </a:defRPr>
-            </a:pPr>
-            <a:r>
-              <a:t>Extracting clinically validated indicators from raw sound waves</a:t>
-            </a:r>
-          </a:p>
-        </p:txBody>
-      </p:sp>
-      <p:sp>
-        <p:nvSpPr>
-          <p:cNvPr id="6" name="Rounded Rectangle 5"/>
-          <p:cNvSpPr/>
-          <p:nvPr/>
-        </p:nvSpPr>
-        <p:spPr>
-          <a:xfrm>
-            <a:off x="731520" y="1920240"/>
-            <a:ext cx="10728655" cy="3474720"/>
+            <a:off x="914400" y="1645920"/>
+            <a:ext cx="5029200" cy="2011680"/>
           </a:xfrm>
           <a:prstGeom prst="roundRect">
             <a:avLst/>
           </a:prstGeom>
           <a:solidFill>
-            <a:srgbClr val="121826"/>
+            <a:srgbClr val="1E293B"/>
           </a:solidFill>
-          <a:ln w="12700">
+          <a:ln>
             <a:solidFill>
-              <a:srgbClr val="1E293B"/>
+              <a:srgbClr val="334155"/>
             </a:solidFill>
           </a:ln>
         </p:spPr>
@@ -4429,136 +4110,67 @@
           </a:fontRef>
         </p:style>
         <p:txBody>
-          <a:bodyPr rtlCol="0" anchor="ctr"/>
-          <a:lstStyle/>
-          <a:p>
-            <a:pPr algn="ctr"/>
-          </a:p>
-        </p:txBody>
-      </p:sp>
-      <p:sp>
-        <p:nvSpPr>
-          <p:cNvPr id="7" name="TextBox 6"/>
-          <p:cNvSpPr txBox="1"/>
+          <a:bodyPr rtlCol="0" anchor="ctr" wrap="square"/>
+          <a:lstStyle/>
+          <a:p>
+            <a:pPr algn="ctr">
+              <a:defRPr sz="1500" b="1">
+                <a:solidFill>
+                  <a:srgbClr val="38BDF8"/>
+                </a:solidFill>
+                <a:latin typeface="Calibri"/>
+              </a:defRPr>
+            </a:pPr>
+            <a:r>
+              <a:t>1. Fundamental Pitch (F0)</a:t>
+            </a:r>
+          </a:p>
+          <a:p>
+            <a:pPr>
+              <a:spcBef>
+                <a:spcPts val="400"/>
+              </a:spcBef>
+              <a:defRPr sz="1300">
+                <a:solidFill>
+                  <a:srgbClr val="FFFFFF"/>
+                </a:solidFill>
+                <a:latin typeface="Calibri"/>
+              </a:defRPr>
+            </a:pPr>
+            <a:r>
+              <a:t>Tracks vocal cord frequency</a:t>
+            </a:r>
+            <a:br/>
+            <a:r>
+              <a:t>Normal: 85 - 255 Hz</a:t>
+            </a:r>
+            <a:br/>
+            <a:r>
+              <a:t>Clinical insight: Rapid tremor indicates acute shock or autonomic panic.</a:t>
+            </a:r>
+          </a:p>
+        </p:txBody>
+      </p:sp>
+      <p:sp>
+        <p:nvSpPr>
+          <p:cNvPr id="5" name="Rounded Rectangle 4"/>
+          <p:cNvSpPr/>
           <p:nvPr/>
         </p:nvSpPr>
         <p:spPr>
           <a:xfrm>
-            <a:off x="1005840" y="2103120"/>
-            <a:ext cx="10149840" cy="3108960"/>
-          </a:xfrm>
-          <a:prstGeom prst="rect">
-            <a:avLst/>
-          </a:prstGeom>
-          <a:noFill/>
-        </p:spPr>
-        <p:txBody>
-          <a:bodyPr wrap="square">
-            <a:spAutoFit/>
-          </a:bodyPr>
-          <a:lstStyle/>
-          <a:p>
-            <a:pPr>
-              <a:spcAft>
-                <a:spcPts val="1000"/>
-              </a:spcAft>
-              <a:defRPr sz="1500">
-                <a:solidFill>
-                  <a:srgbClr val="F8FAFC"/>
-                </a:solidFill>
-                <a:latin typeface="Arial"/>
-              </a:defRPr>
-            </a:pPr>
-            <a:r>
-              <a:t>F₀ (Fundamental Pitch): Tracks pitch micro-tremors and autonomic shock reactions.</a:t>
-            </a:r>
-          </a:p>
-          <a:p>
-            <a:pPr>
-              <a:spcAft>
-                <a:spcPts val="1000"/>
-              </a:spcAft>
-              <a:defRPr sz="1500">
-                <a:solidFill>
-                  <a:srgbClr val="F8FAFC"/>
-                </a:solidFill>
-                <a:latin typeface="Arial"/>
-              </a:defRPr>
-            </a:pPr>
-            <a:r>
-              <a:t>Jitter (Cycle-to-Cycle Perturbation): Flags neuromuscular instability in the vocal folds (&gt; 2.5%).</a:t>
-            </a:r>
-          </a:p>
-          <a:p>
-            <a:pPr>
-              <a:spcAft>
-                <a:spcPts val="1000"/>
-              </a:spcAft>
-              <a:defRPr sz="1500">
-                <a:solidFill>
-                  <a:srgbClr val="F8FAFC"/>
-                </a:solidFill>
-                <a:latin typeface="Arial"/>
-              </a:defRPr>
-            </a:pPr>
-            <a:r>
-              <a:t>HNR (Harmonics-to-Noise Ratio): Quantifies turbulent breath noise &amp; acute hypoxia (&lt; 12 dB).</a:t>
-            </a:r>
-          </a:p>
-          <a:p>
-            <a:pPr>
-              <a:spcAft>
-                <a:spcPts val="1000"/>
-              </a:spcAft>
-              <a:defRPr sz="1500">
-                <a:solidFill>
-                  <a:srgbClr val="F8FAFC"/>
-                </a:solidFill>
-                <a:latin typeface="Arial"/>
-              </a:defRPr>
-            </a:pPr>
-            <a:r>
-              <a:t>Formants F₁ &amp; F₂ (LPC Resonances): Measures vowel space collapse &amp; dysarthric centralization.</a:t>
-            </a:r>
-          </a:p>
-          <a:p>
-            <a:pPr>
-              <a:spcAft>
-                <a:spcPts val="1000"/>
-              </a:spcAft>
-              <a:defRPr sz="1500">
-                <a:solidFill>
-                  <a:srgbClr val="F8FAFC"/>
-                </a:solidFill>
-                <a:latin typeface="Arial"/>
-              </a:defRPr>
-            </a:pPr>
-            <a:r>
-              <a:t>CSI Score (Composite Stroke/Hypoxia Index): Weighted multi-biomarker score from 0.0 to 1.0.</a:t>
-            </a:r>
-          </a:p>
-        </p:txBody>
-      </p:sp>
-      <p:sp>
-        <p:nvSpPr>
-          <p:cNvPr id="8" name="Rounded Rectangle 7"/>
-          <p:cNvSpPr/>
-          <p:nvPr/>
-        </p:nvSpPr>
-        <p:spPr>
-          <a:xfrm>
-            <a:off x="731520" y="5577840"/>
-            <a:ext cx="10728655" cy="731520"/>
+            <a:off x="6217920" y="1645920"/>
+            <a:ext cx="5029200" cy="2011680"/>
           </a:xfrm>
           <a:prstGeom prst="roundRect">
             <a:avLst/>
           </a:prstGeom>
           <a:solidFill>
-            <a:srgbClr val="0F172A"/>
+            <a:srgbClr val="1E293B"/>
           </a:solidFill>
-          <a:ln w="12700">
+          <a:ln>
             <a:solidFill>
-              <a:srgbClr val="06B6D4"/>
+              <a:srgbClr val="334155"/>
             </a:solidFill>
           </a:ln>
         </p:spPr>
@@ -4577,45 +4189,201 @@
           </a:fontRef>
         </p:style>
         <p:txBody>
-          <a:bodyPr rtlCol="0" anchor="ctr"/>
-          <a:lstStyle/>
-          <a:p>
-            <a:pPr algn="ctr"/>
-          </a:p>
-        </p:txBody>
-      </p:sp>
-      <p:sp>
-        <p:nvSpPr>
-          <p:cNvPr id="9" name="TextBox 8"/>
-          <p:cNvSpPr txBox="1"/>
+          <a:bodyPr rtlCol="0" anchor="ctr" wrap="square"/>
+          <a:lstStyle/>
+          <a:p>
+            <a:pPr algn="ctr">
+              <a:defRPr sz="1500" b="1">
+                <a:solidFill>
+                  <a:srgbClr val="FB7185"/>
+                </a:solidFill>
+                <a:latin typeface="Calibri"/>
+              </a:defRPr>
+            </a:pPr>
+            <a:r>
+              <a:t>2. Jitter (Perturbation)</a:t>
+            </a:r>
+          </a:p>
+          <a:p>
+            <a:pPr>
+              <a:spcBef>
+                <a:spcPts val="400"/>
+              </a:spcBef>
+              <a:defRPr sz="1300">
+                <a:solidFill>
+                  <a:srgbClr val="FFFFFF"/>
+                </a:solidFill>
+                <a:latin typeface="Calibri"/>
+              </a:defRPr>
+            </a:pPr>
+            <a:r>
+              <a:t>Cycle-to-cycle frequency variation</a:t>
+            </a:r>
+            <a:br/>
+            <a:r>
+              <a:t>Normal: &lt; 1.04% | Alert: &gt; 2.50%</a:t>
+            </a:r>
+            <a:br/>
+            <a:r>
+              <a:t>Clinical insight: Vocal fold weakness from unilateral facial stroke causes jitter to spike.</a:t>
+            </a:r>
+          </a:p>
+        </p:txBody>
+      </p:sp>
+      <p:sp>
+        <p:nvSpPr>
+          <p:cNvPr id="6" name="Rounded Rectangle 5"/>
+          <p:cNvSpPr/>
           <p:nvPr/>
         </p:nvSpPr>
         <p:spPr>
           <a:xfrm>
-            <a:off x="914400" y="5715000"/>
-            <a:ext cx="10332720" cy="457200"/>
+            <a:off x="914400" y="3931920"/>
+            <a:ext cx="5029200" cy="2011680"/>
           </a:xfrm>
-          <a:prstGeom prst="rect">
+          <a:prstGeom prst="roundRect">
             <a:avLst/>
           </a:prstGeom>
-          <a:noFill/>
+          <a:solidFill>
+            <a:srgbClr val="1E293B"/>
+          </a:solidFill>
+          <a:ln>
+            <a:solidFill>
+              <a:srgbClr val="334155"/>
+            </a:solidFill>
+          </a:ln>
         </p:spPr>
-        <p:txBody>
-          <a:bodyPr wrap="square">
-            <a:spAutoFit/>
-          </a:bodyPr>
-          <a:lstStyle/>
+        <p:style>
+          <a:lnRef idx="1">
+            <a:schemeClr val="accent1"/>
+          </a:lnRef>
+          <a:fillRef idx="3">
+            <a:schemeClr val="accent1"/>
+          </a:fillRef>
+          <a:effectRef idx="2">
+            <a:schemeClr val="accent1"/>
+          </a:effectRef>
+          <a:fontRef idx="minor">
+            <a:schemeClr val="lt1"/>
+          </a:fontRef>
+        </p:style>
+        <p:txBody>
+          <a:bodyPr rtlCol="0" anchor="ctr" wrap="square"/>
+          <a:lstStyle/>
+          <a:p>
+            <a:pPr algn="ctr">
+              <a:defRPr sz="1500" b="1">
+                <a:solidFill>
+                  <a:srgbClr val="34D399"/>
+                </a:solidFill>
+                <a:latin typeface="Calibri"/>
+              </a:defRPr>
+            </a:pPr>
+            <a:r>
+              <a:t>3. Harmonics-to-Noise (HNR)</a:t>
+            </a:r>
+          </a:p>
           <a:p>
             <a:pPr>
-              <a:defRPr sz="1300" b="1">
-                <a:solidFill>
-                  <a:srgbClr val="06B6D4"/>
-                </a:solidFill>
-                <a:latin typeface="Arial"/>
+              <a:spcBef>
+                <a:spcPts val="400"/>
+              </a:spcBef>
+              <a:defRPr sz="1300">
+                <a:solidFill>
+                  <a:srgbClr val="FFFFFF"/>
+                </a:solidFill>
+                <a:latin typeface="Calibri"/>
               </a:defRPr>
             </a:pPr>
             <a:r>
-              <a:t>⚡  Facial paralysis collapses vowel space symmetry before human ears can detect slurring.</a:t>
+              <a:t>Voice purity vs. turbulent air</a:t>
+            </a:r>
+            <a:br/>
+            <a:r>
+              <a:t>Normal: &gt; 18 dB | Critical: &lt; 12 dB</a:t>
+            </a:r>
+            <a:br/>
+            <a:r>
+              <a:t>Clinical insight: When lungs lack oxygen (hypoxia), turbulent breath noise takes over.</a:t>
+            </a:r>
+          </a:p>
+        </p:txBody>
+      </p:sp>
+      <p:sp>
+        <p:nvSpPr>
+          <p:cNvPr id="7" name="Rounded Rectangle 6"/>
+          <p:cNvSpPr/>
+          <p:nvPr/>
+        </p:nvSpPr>
+        <p:spPr>
+          <a:xfrm>
+            <a:off x="6217920" y="3931920"/>
+            <a:ext cx="5029200" cy="2011680"/>
+          </a:xfrm>
+          <a:prstGeom prst="roundRect">
+            <a:avLst/>
+          </a:prstGeom>
+          <a:solidFill>
+            <a:srgbClr val="1E293B"/>
+          </a:solidFill>
+          <a:ln>
+            <a:solidFill>
+              <a:srgbClr val="334155"/>
+            </a:solidFill>
+          </a:ln>
+        </p:spPr>
+        <p:style>
+          <a:lnRef idx="1">
+            <a:schemeClr val="accent1"/>
+          </a:lnRef>
+          <a:fillRef idx="3">
+            <a:schemeClr val="accent1"/>
+          </a:fillRef>
+          <a:effectRef idx="2">
+            <a:schemeClr val="accent1"/>
+          </a:effectRef>
+          <a:fontRef idx="minor">
+            <a:schemeClr val="lt1"/>
+          </a:fontRef>
+        </p:style>
+        <p:txBody>
+          <a:bodyPr rtlCol="0" anchor="ctr" wrap="square"/>
+          <a:lstStyle/>
+          <a:p>
+            <a:pPr algn="ctr">
+              <a:defRPr sz="1500" b="1">
+                <a:solidFill>
+                  <a:srgbClr val="38BDF8"/>
+                </a:solidFill>
+                <a:latin typeface="Calibri"/>
+              </a:defRPr>
+            </a:pPr>
+            <a:r>
+              <a:t>4. Formants (F1, F2)</a:t>
+            </a:r>
+          </a:p>
+          <a:p>
+            <a:pPr>
+              <a:spcBef>
+                <a:spcPts val="400"/>
+              </a:spcBef>
+              <a:defRPr sz="1300">
+                <a:solidFill>
+                  <a:srgbClr val="FFFFFF"/>
+                </a:solidFill>
+                <a:latin typeface="Calibri"/>
+              </a:defRPr>
+            </a:pPr>
+            <a:r>
+              <a:t>Vocal tract resonant shapes</a:t>
+            </a:r>
+            <a:br/>
+            <a:r>
+              <a:t>Healthy vowels disperse widely</a:t>
+            </a:r>
+            <a:br/>
+            <a:r>
+              <a:t>Clinical insight: Dysarthria (slurring) collapses tongue movement: F2 centralizes to 1500 Hz.</a:t>
             </a:r>
           </a:p>
         </p:txBody>
@@ -4653,7 +4421,7 @@
             <a:avLst/>
           </a:prstGeom>
           <a:solidFill>
-            <a:srgbClr val="090D16"/>
+            <a:srgbClr val="0F172A"/>
           </a:solidFill>
           <a:ln>
             <a:noFill/>
@@ -4689,8 +4457,8 @@
         </p:nvSpPr>
         <p:spPr>
           <a:xfrm>
-            <a:off x="731520" y="457200"/>
-            <a:ext cx="10698480" cy="365760"/>
+            <a:off x="914400" y="548640"/>
+            <a:ext cx="10332720" cy="914400"/>
           </a:xfrm>
           <a:prstGeom prst="rect">
             <a:avLst/>
@@ -4698,117 +4466,58 @@
           <a:noFill/>
         </p:spPr>
         <p:txBody>
-          <a:bodyPr wrap="square">
+          <a:bodyPr wrap="none">
             <a:spAutoFit/>
           </a:bodyPr>
           <a:lstStyle/>
           <a:p>
             <a:pPr>
-              <a:defRPr sz="1100" b="1">
-                <a:solidFill>
-                  <a:srgbClr val="06B6D4"/>
-                </a:solidFill>
-                <a:latin typeface="Arial"/>
+              <a:defRPr sz="2800" b="1">
+                <a:solidFill>
+                  <a:srgbClr val="FFFFFF"/>
+                </a:solidFill>
+                <a:latin typeface="Calibri"/>
               </a:defRPr>
             </a:pPr>
             <a:r>
-              <a:t>CLINICAL SCENARIO</a:t>
-            </a:r>
-          </a:p>
-        </p:txBody>
-      </p:sp>
-      <p:sp>
-        <p:nvSpPr>
-          <p:cNvPr id="4" name="TextBox 3"/>
-          <p:cNvSpPr txBox="1"/>
+              <a:t>Real Scenario: Catching an Acute Stroke Live</a:t>
+            </a:r>
+          </a:p>
+          <a:p>
+            <a:pPr>
+              <a:defRPr sz="1400">
+                <a:solidFill>
+                  <a:srgbClr val="94A3B8"/>
+                </a:solidFill>
+                <a:latin typeface="Calibri"/>
+              </a:defRPr>
+            </a:pPr>
+            <a:r>
+              <a:t>How NeuroVocal AI turns a misclassified routine call into a life-saving dispatch.</a:t>
+            </a:r>
+          </a:p>
+        </p:txBody>
+      </p:sp>
+      <p:sp>
+        <p:nvSpPr>
+          <p:cNvPr id="4" name="Rounded Rectangle 3"/>
+          <p:cNvSpPr/>
           <p:nvPr/>
         </p:nvSpPr>
         <p:spPr>
           <a:xfrm>
-            <a:off x="731520" y="777240"/>
-            <a:ext cx="10698480" cy="640080"/>
-          </a:xfrm>
-          <a:prstGeom prst="rect">
-            <a:avLst/>
-          </a:prstGeom>
-          <a:noFill/>
-        </p:spPr>
-        <p:txBody>
-          <a:bodyPr wrap="square">
-            <a:spAutoFit/>
-          </a:bodyPr>
-          <a:lstStyle/>
-          <a:p>
-            <a:pPr>
-              <a:defRPr sz="2800" b="1">
-                <a:solidFill>
-                  <a:srgbClr val="F8FAFC"/>
-                </a:solidFill>
-                <a:latin typeface="Arial"/>
-              </a:defRPr>
-            </a:pPr>
-            <a:r>
-              <a:t>Real-Life Demonstration: Code Red Catch</a:t>
-            </a:r>
-          </a:p>
-        </p:txBody>
-      </p:sp>
-      <p:sp>
-        <p:nvSpPr>
-          <p:cNvPr id="5" name="TextBox 4"/>
-          <p:cNvSpPr txBox="1"/>
-          <p:nvPr/>
-        </p:nvSpPr>
-        <p:spPr>
-          <a:xfrm>
-            <a:off x="731520" y="1371600"/>
-            <a:ext cx="10698480" cy="457200"/>
-          </a:xfrm>
-          <a:prstGeom prst="rect">
-            <a:avLst/>
-          </a:prstGeom>
-          <a:noFill/>
-        </p:spPr>
-        <p:txBody>
-          <a:bodyPr wrap="square">
-            <a:spAutoFit/>
-          </a:bodyPr>
-          <a:lstStyle/>
-          <a:p>
-            <a:pPr>
-              <a:defRPr sz="1400">
-                <a:solidFill>
-                  <a:srgbClr val="94A3B8"/>
-                </a:solidFill>
-                <a:latin typeface="Arial"/>
-              </a:defRPr>
-            </a:pPr>
-            <a:r>
-              <a:t>Comparison between conventional AI vs. NeuroVocal AI</a:t>
-            </a:r>
-          </a:p>
-        </p:txBody>
-      </p:sp>
-      <p:sp>
-        <p:nvSpPr>
-          <p:cNvPr id="6" name="Rounded Rectangle 5"/>
-          <p:cNvSpPr/>
-          <p:nvPr/>
-        </p:nvSpPr>
-        <p:spPr>
-          <a:xfrm>
-            <a:off x="731520" y="1920240"/>
-            <a:ext cx="10728655" cy="3474720"/>
+            <a:off x="914400" y="1645920"/>
+            <a:ext cx="10332720" cy="1005840"/>
           </a:xfrm>
           <a:prstGeom prst="roundRect">
             <a:avLst/>
           </a:prstGeom>
           <a:solidFill>
-            <a:srgbClr val="121826"/>
+            <a:srgbClr val="1E293B"/>
           </a:solidFill>
           <a:ln w="12700">
             <a:solidFill>
-              <a:srgbClr val="1E293B"/>
+              <a:srgbClr val="334155"/>
             </a:solidFill>
           </a:ln>
         </p:spPr>
@@ -4827,136 +4536,59 @@
           </a:fontRef>
         </p:style>
         <p:txBody>
-          <a:bodyPr rtlCol="0" anchor="ctr"/>
-          <a:lstStyle/>
-          <a:p>
-            <a:pPr algn="ctr"/>
-          </a:p>
-        </p:txBody>
-      </p:sp>
-      <p:sp>
-        <p:nvSpPr>
-          <p:cNvPr id="7" name="TextBox 6"/>
-          <p:cNvSpPr txBox="1"/>
+          <a:bodyPr rtlCol="0" anchor="ctr" wrap="square"/>
+          <a:lstStyle/>
+          <a:p>
+            <a:pPr algn="ctr">
+              <a:defRPr sz="1500" b="1">
+                <a:solidFill>
+                  <a:srgbClr val="FFFFFF"/>
+                </a:solidFill>
+                <a:latin typeface="Calibri"/>
+              </a:defRPr>
+            </a:pPr>
+            <a:r>
+              <a:t>Step 1: The Caller</a:t>
+            </a:r>
+          </a:p>
+          <a:p>
+            <a:pPr>
+              <a:spcBef>
+                <a:spcPts val="200"/>
+              </a:spcBef>
+              <a:defRPr sz="1300">
+                <a:solidFill>
+                  <a:srgbClr val="FFFFFF"/>
+                </a:solidFill>
+                <a:latin typeface="Calibri"/>
+              </a:defRPr>
+            </a:pPr>
+            <a:r>
+              <a:t>An elderly caller rings helpline 112: 'Hello... I feel a bit lightheaded, and my right hand feels heavy.'</a:t>
+            </a:r>
+          </a:p>
+        </p:txBody>
+      </p:sp>
+      <p:sp>
+        <p:nvSpPr>
+          <p:cNvPr id="5" name="Rounded Rectangle 4"/>
+          <p:cNvSpPr/>
           <p:nvPr/>
         </p:nvSpPr>
         <p:spPr>
           <a:xfrm>
-            <a:off x="1005840" y="2103120"/>
-            <a:ext cx="10149840" cy="3108960"/>
-          </a:xfrm>
-          <a:prstGeom prst="rect">
-            <a:avLst/>
-          </a:prstGeom>
-          <a:noFill/>
-        </p:spPr>
-        <p:txBody>
-          <a:bodyPr wrap="square">
-            <a:spAutoFit/>
-          </a:bodyPr>
-          <a:lstStyle/>
-          <a:p>
-            <a:pPr>
-              <a:spcAft>
-                <a:spcPts val="1000"/>
-              </a:spcAft>
-              <a:defRPr sz="1500">
-                <a:solidFill>
-                  <a:srgbClr val="F8FAFC"/>
-                </a:solidFill>
-                <a:latin typeface="Arial"/>
-              </a:defRPr>
-            </a:pPr>
-            <a:r>
-              <a:t>The Call: Elderly caller says calmly: 'I feel a bit lightheaded, and my hand feels heavy.'</a:t>
-            </a:r>
-          </a:p>
-          <a:p>
-            <a:pPr>
-              <a:spcAft>
-                <a:spcPts val="1000"/>
-              </a:spcAft>
-              <a:defRPr sz="1500">
-                <a:solidFill>
-                  <a:srgbClr val="F8FAFC"/>
-                </a:solidFill>
-                <a:latin typeface="Arial"/>
-              </a:defRPr>
-            </a:pPr>
-            <a:r>
-              <a:t>Standard AI Bot: Classifies as mild fatigue, suggests drinking water and booking a clinic visit.</a:t>
-            </a:r>
-          </a:p>
-          <a:p>
-            <a:pPr>
-              <a:spcAft>
-                <a:spcPts val="1000"/>
-              </a:spcAft>
-              <a:defRPr sz="1500">
-                <a:solidFill>
-                  <a:srgbClr val="F8FAFC"/>
-                </a:solidFill>
-                <a:latin typeface="Arial"/>
-              </a:defRPr>
-            </a:pPr>
-            <a:r>
-              <a:t>NeuroVocal AI Conversational Stream: Keeps patient calm: 'Help is being coordinated, stay seated.'</a:t>
-            </a:r>
-          </a:p>
-          <a:p>
-            <a:pPr>
-              <a:spcAft>
-                <a:spcPts val="1000"/>
-              </a:spcAft>
-              <a:defRPr sz="1500">
-                <a:solidFill>
-                  <a:srgbClr val="F8FAFC"/>
-                </a:solidFill>
-                <a:latin typeface="Arial"/>
-              </a:defRPr>
-            </a:pPr>
-            <a:r>
-              <a:t>NeuroVocal AI DSP Scanner: Detects 35% drop in vocal tract symmetry + F2 centralization to 1500Hz.</a:t>
-            </a:r>
-          </a:p>
-          <a:p>
-            <a:pPr>
-              <a:spcAft>
-                <a:spcPts val="1000"/>
-              </a:spcAft>
-              <a:defRPr sz="1500">
-                <a:solidFill>
-                  <a:srgbClr val="F8FAFC"/>
-                </a:solidFill>
-                <a:latin typeface="Arial"/>
-              </a:defRPr>
-            </a:pPr>
-            <a:r>
-              <a:t>Dispatcher Action: Instantly flashes 'CODE RED: SUSPECTED STROKE' with GPS location on HUD.</a:t>
-            </a:r>
-          </a:p>
-        </p:txBody>
-      </p:sp>
-      <p:sp>
-        <p:nvSpPr>
-          <p:cNvPr id="8" name="Rounded Rectangle 7"/>
-          <p:cNvSpPr/>
-          <p:nvPr/>
-        </p:nvSpPr>
-        <p:spPr>
-          <a:xfrm>
-            <a:off x="731520" y="5577840"/>
-            <a:ext cx="10728655" cy="731520"/>
+            <a:off x="914400" y="2834640"/>
+            <a:ext cx="10332720" cy="1005840"/>
           </a:xfrm>
           <a:prstGeom prst="roundRect">
             <a:avLst/>
           </a:prstGeom>
           <a:solidFill>
-            <a:srgbClr val="0F172A"/>
+            <a:srgbClr val="1E293B"/>
           </a:solidFill>
           <a:ln w="12700">
             <a:solidFill>
-              <a:srgbClr val="06B6D4"/>
+              <a:srgbClr val="34D399"/>
             </a:solidFill>
           </a:ln>
         </p:spPr>
@@ -4975,45 +4607,177 @@
           </a:fontRef>
         </p:style>
         <p:txBody>
-          <a:bodyPr rtlCol="0" anchor="ctr"/>
-          <a:lstStyle/>
-          <a:p>
-            <a:pPr algn="ctr"/>
-          </a:p>
-        </p:txBody>
-      </p:sp>
-      <p:sp>
-        <p:nvSpPr>
-          <p:cNvPr id="9" name="TextBox 8"/>
-          <p:cNvSpPr txBox="1"/>
+          <a:bodyPr rtlCol="0" anchor="ctr" wrap="square"/>
+          <a:lstStyle/>
+          <a:p>
+            <a:pPr algn="ctr">
+              <a:defRPr sz="1500" b="1">
+                <a:solidFill>
+                  <a:srgbClr val="34D399"/>
+                </a:solidFill>
+                <a:latin typeface="Calibri"/>
+              </a:defRPr>
+            </a:pPr>
+            <a:r>
+              <a:t>Step 2: Stream 1 Keeps Them Calm</a:t>
+            </a:r>
+          </a:p>
+          <a:p>
+            <a:pPr>
+              <a:spcBef>
+                <a:spcPts val="200"/>
+              </a:spcBef>
+              <a:defRPr sz="1300">
+                <a:solidFill>
+                  <a:srgbClr val="FFFFFF"/>
+                </a:solidFill>
+                <a:latin typeface="Calibri"/>
+              </a:defRPr>
+            </a:pPr>
+            <a:r>
+              <a:t>The conversational bot replies gently: 'I hear you. Please stay seated right where you are. What is your address?'</a:t>
+            </a:r>
+          </a:p>
+        </p:txBody>
+      </p:sp>
+      <p:sp>
+        <p:nvSpPr>
+          <p:cNvPr id="6" name="Rounded Rectangle 5"/>
+          <p:cNvSpPr/>
           <p:nvPr/>
         </p:nvSpPr>
         <p:spPr>
           <a:xfrm>
-            <a:off x="914400" y="5715000"/>
-            <a:ext cx="10332720" cy="457200"/>
+            <a:off x="914400" y="4023360"/>
+            <a:ext cx="10332720" cy="1005840"/>
           </a:xfrm>
-          <a:prstGeom prst="rect">
+          <a:prstGeom prst="roundRect">
             <a:avLst/>
           </a:prstGeom>
-          <a:noFill/>
+          <a:solidFill>
+            <a:srgbClr val="1E293B"/>
+          </a:solidFill>
+          <a:ln w="12700">
+            <a:solidFill>
+              <a:srgbClr val="38BDF8"/>
+            </a:solidFill>
+          </a:ln>
         </p:spPr>
-        <p:txBody>
-          <a:bodyPr wrap="square">
-            <a:spAutoFit/>
-          </a:bodyPr>
-          <a:lstStyle/>
+        <p:style>
+          <a:lnRef idx="1">
+            <a:schemeClr val="accent1"/>
+          </a:lnRef>
+          <a:fillRef idx="3">
+            <a:schemeClr val="accent1"/>
+          </a:fillRef>
+          <a:effectRef idx="2">
+            <a:schemeClr val="accent1"/>
+          </a:effectRef>
+          <a:fontRef idx="minor">
+            <a:schemeClr val="lt1"/>
+          </a:fontRef>
+        </p:style>
+        <p:txBody>
+          <a:bodyPr rtlCol="0" anchor="ctr" wrap="square"/>
+          <a:lstStyle/>
+          <a:p>
+            <a:pPr algn="ctr">
+              <a:defRPr sz="1500" b="1">
+                <a:solidFill>
+                  <a:srgbClr val="38BDF8"/>
+                </a:solidFill>
+                <a:latin typeface="Calibri"/>
+              </a:defRPr>
+            </a:pPr>
+            <a:r>
+              <a:t>Step 3: Stream 2 Detects Vocal Collapse</a:t>
+            </a:r>
+          </a:p>
           <a:p>
             <a:pPr>
-              <a:defRPr sz="1300" b="1">
-                <a:solidFill>
-                  <a:srgbClr val="06B6D4"/>
-                </a:solidFill>
-                <a:latin typeface="Arial"/>
+              <a:spcBef>
+                <a:spcPts val="200"/>
+              </a:spcBef>
+              <a:defRPr sz="1300">
+                <a:solidFill>
+                  <a:srgbClr val="FFFFFF"/>
+                </a:solidFill>
+                <a:latin typeface="Calibri"/>
               </a:defRPr>
             </a:pPr>
             <a:r>
-              <a:t>⚡  Turned a misclassified routine call into an immediate high-priority life-saving dispatch.</a:t>
+              <a:t>The DSP scanner notes the caller's vowel space symmetry dropped 35% and F2 collapsed to 1490 Hz with 15% jitter.</a:t>
+            </a:r>
+          </a:p>
+        </p:txBody>
+      </p:sp>
+      <p:sp>
+        <p:nvSpPr>
+          <p:cNvPr id="7" name="Rounded Rectangle 6"/>
+          <p:cNvSpPr/>
+          <p:nvPr/>
+        </p:nvSpPr>
+        <p:spPr>
+          <a:xfrm>
+            <a:off x="914400" y="5212080"/>
+            <a:ext cx="10332720" cy="1005840"/>
+          </a:xfrm>
+          <a:prstGeom prst="roundRect">
+            <a:avLst/>
+          </a:prstGeom>
+          <a:solidFill>
+            <a:srgbClr val="1E293B"/>
+          </a:solidFill>
+          <a:ln w="12700">
+            <a:solidFill>
+              <a:srgbClr val="FB7185"/>
+            </a:solidFill>
+          </a:ln>
+        </p:spPr>
+        <p:style>
+          <a:lnRef idx="1">
+            <a:schemeClr val="accent1"/>
+          </a:lnRef>
+          <a:fillRef idx="3">
+            <a:schemeClr val="accent1"/>
+          </a:fillRef>
+          <a:effectRef idx="2">
+            <a:schemeClr val="accent1"/>
+          </a:effectRef>
+          <a:fontRef idx="minor">
+            <a:schemeClr val="lt1"/>
+          </a:fontRef>
+        </p:style>
+        <p:txBody>
+          <a:bodyPr rtlCol="0" anchor="ctr" wrap="square"/>
+          <a:lstStyle/>
+          <a:p>
+            <a:pPr algn="ctr">
+              <a:defRPr sz="1500" b="1">
+                <a:solidFill>
+                  <a:srgbClr val="FB7185"/>
+                </a:solidFill>
+                <a:latin typeface="Calibri"/>
+              </a:defRPr>
+            </a:pPr>
+            <a:r>
+              <a:t>Step 4: Dispatcher Emergency Alert</a:t>
+            </a:r>
+          </a:p>
+          <a:p>
+            <a:pPr>
+              <a:spcBef>
+                <a:spcPts val="200"/>
+              </a:spcBef>
+              <a:defRPr sz="1300">
+                <a:solidFill>
+                  <a:srgbClr val="FFFFFF"/>
+                </a:solidFill>
+                <a:latin typeface="Calibri"/>
+              </a:defRPr>
+            </a:pPr>
+            <a:r>
+              <a:t>The hospital dashboard flashes: 'CODE RED: ACUTE STROKE BIOMARKER DETECTED' with immediate GPS coordinates.</a:t>
             </a:r>
           </a:p>
         </p:txBody>
@@ -5051,7 +4815,7 @@
             <a:avLst/>
           </a:prstGeom>
           <a:solidFill>
-            <a:srgbClr val="090D16"/>
+            <a:srgbClr val="0F172A"/>
           </a:solidFill>
           <a:ln>
             <a:noFill/>
@@ -5087,8 +4851,8 @@
         </p:nvSpPr>
         <p:spPr>
           <a:xfrm>
-            <a:off x="731520" y="457200"/>
-            <a:ext cx="10698480" cy="365760"/>
+            <a:off x="914400" y="548640"/>
+            <a:ext cx="10332720" cy="914400"/>
           </a:xfrm>
           <a:prstGeom prst="rect">
             <a:avLst/>
@@ -5096,117 +4860,58 @@
           <a:noFill/>
         </p:spPr>
         <p:txBody>
-          <a:bodyPr wrap="square">
+          <a:bodyPr wrap="none">
             <a:spAutoFit/>
           </a:bodyPr>
           <a:lstStyle/>
           <a:p>
             <a:pPr>
-              <a:defRPr sz="1100" b="1">
-                <a:solidFill>
-                  <a:srgbClr val="06B6D4"/>
-                </a:solidFill>
-                <a:latin typeface="Arial"/>
+              <a:defRPr sz="2800" b="1">
+                <a:solidFill>
+                  <a:srgbClr val="FFFFFF"/>
+                </a:solidFill>
+                <a:latin typeface="Calibri"/>
               </a:defRPr>
             </a:pPr>
             <a:r>
-              <a:t>FULL-STACK ARCHITECTURE</a:t>
-            </a:r>
-          </a:p>
-        </p:txBody>
-      </p:sp>
-      <p:sp>
-        <p:nvSpPr>
-          <p:cNvPr id="4" name="TextBox 3"/>
-          <p:cNvSpPr txBox="1"/>
+              <a:t>Engineering Deep-Dive: 25 Hz Real-Time Telemetry</a:t>
+            </a:r>
+          </a:p>
+          <a:p>
+            <a:pPr>
+              <a:defRPr sz="1400">
+                <a:solidFill>
+                  <a:srgbClr val="94A3B8"/>
+                </a:solidFill>
+                <a:latin typeface="Calibri"/>
+              </a:defRPr>
+            </a:pPr>
+            <a:r>
+              <a:t>Actual benchmark numbers tested on our laptop hardware with test_client.py.</a:t>
+            </a:r>
+          </a:p>
+        </p:txBody>
+      </p:sp>
+      <p:sp>
+        <p:nvSpPr>
+          <p:cNvPr id="4" name="Rounded Rectangle 3"/>
+          <p:cNvSpPr/>
           <p:nvPr/>
         </p:nvSpPr>
         <p:spPr>
           <a:xfrm>
-            <a:off x="731520" y="777240"/>
-            <a:ext cx="10698480" cy="640080"/>
-          </a:xfrm>
-          <a:prstGeom prst="rect">
-            <a:avLst/>
-          </a:prstGeom>
-          <a:noFill/>
-        </p:spPr>
-        <p:txBody>
-          <a:bodyPr wrap="square">
-            <a:spAutoFit/>
-          </a:bodyPr>
-          <a:lstStyle/>
-          <a:p>
-            <a:pPr>
-              <a:defRPr sz="2800" b="1">
-                <a:solidFill>
-                  <a:srgbClr val="F8FAFC"/>
-                </a:solidFill>
-                <a:latin typeface="Arial"/>
-              </a:defRPr>
-            </a:pPr>
-            <a:r>
-              <a:t>Real-Time Systems Engineering</a:t>
-            </a:r>
-          </a:p>
-        </p:txBody>
-      </p:sp>
-      <p:sp>
-        <p:nvSpPr>
-          <p:cNvPr id="5" name="TextBox 4"/>
-          <p:cNvSpPr txBox="1"/>
-          <p:nvPr/>
-        </p:nvSpPr>
-        <p:spPr>
-          <a:xfrm>
-            <a:off x="731520" y="1371600"/>
-            <a:ext cx="10698480" cy="457200"/>
-          </a:xfrm>
-          <a:prstGeom prst="rect">
-            <a:avLst/>
-          </a:prstGeom>
-          <a:noFill/>
-        </p:spPr>
-        <p:txBody>
-          <a:bodyPr wrap="square">
-            <a:spAutoFit/>
-          </a:bodyPr>
-          <a:lstStyle/>
-          <a:p>
-            <a:pPr>
-              <a:defRPr sz="1400">
-                <a:solidFill>
-                  <a:srgbClr val="94A3B8"/>
-                </a:solidFill>
-                <a:latin typeface="Arial"/>
-              </a:defRPr>
-            </a:pPr>
-            <a:r>
-              <a:t>Engineered for deterministic ultra-low latency &amp; zero audio buildup</a:t>
-            </a:r>
-          </a:p>
-        </p:txBody>
-      </p:sp>
-      <p:sp>
-        <p:nvSpPr>
-          <p:cNvPr id="6" name="Rounded Rectangle 5"/>
-          <p:cNvSpPr/>
-          <p:nvPr/>
-        </p:nvSpPr>
-        <p:spPr>
-          <a:xfrm>
-            <a:off x="731520" y="1920240"/>
-            <a:ext cx="10728655" cy="3474720"/>
+            <a:off x="914400" y="1645920"/>
+            <a:ext cx="3291840" cy="1645920"/>
           </a:xfrm>
           <a:prstGeom prst="roundRect">
             <a:avLst/>
           </a:prstGeom>
           <a:solidFill>
-            <a:srgbClr val="121826"/>
+            <a:srgbClr val="1E293B"/>
           </a:solidFill>
           <a:ln w="12700">
             <a:solidFill>
-              <a:srgbClr val="1E293B"/>
+              <a:srgbClr val="38BDF8"/>
             </a:solidFill>
           </a:ln>
         </p:spPr>
@@ -5225,136 +4930,69 @@
           </a:fontRef>
         </p:style>
         <p:txBody>
-          <a:bodyPr rtlCol="0" anchor="ctr"/>
-          <a:lstStyle/>
-          <a:p>
-            <a:pPr algn="ctr"/>
-          </a:p>
-        </p:txBody>
-      </p:sp>
-      <p:sp>
-        <p:nvSpPr>
-          <p:cNvPr id="7" name="TextBox 6"/>
-          <p:cNvSpPr txBox="1"/>
+          <a:bodyPr rtlCol="0" anchor="ctr" wrap="square"/>
+          <a:lstStyle/>
+          <a:p>
+            <a:pPr algn="ctr">
+              <a:defRPr sz="3600" b="1">
+                <a:solidFill>
+                  <a:srgbClr val="38BDF8"/>
+                </a:solidFill>
+                <a:latin typeface="Calibri"/>
+              </a:defRPr>
+            </a:pPr>
+            <a:r>
+              <a:t>25.17 Hz</a:t>
+            </a:r>
+          </a:p>
+          <a:p>
+            <a:pPr>
+              <a:defRPr sz="1400" b="1">
+                <a:solidFill>
+                  <a:srgbClr val="FFFFFF"/>
+                </a:solidFill>
+                <a:latin typeface="Calibri"/>
+              </a:defRPr>
+            </a:pPr>
+            <a:r>
+              <a:t>Measured Delivery Rate</a:t>
+            </a:r>
+          </a:p>
+          <a:p>
+            <a:pPr>
+              <a:defRPr sz="1100">
+                <a:solidFill>
+                  <a:srgbClr val="94A3B8"/>
+                </a:solidFill>
+                <a:latin typeface="Calibri"/>
+              </a:defRPr>
+            </a:pPr>
+            <a:r>
+              <a:t>Target: 25.0 Hz (every 40 ms)</a:t>
+            </a:r>
+          </a:p>
+        </p:txBody>
+      </p:sp>
+      <p:sp>
+        <p:nvSpPr>
+          <p:cNvPr id="5" name="Rounded Rectangle 4"/>
+          <p:cNvSpPr/>
           <p:nvPr/>
         </p:nvSpPr>
         <p:spPr>
           <a:xfrm>
-            <a:off x="1005840" y="2103120"/>
-            <a:ext cx="10149840" cy="3108960"/>
-          </a:xfrm>
-          <a:prstGeom prst="rect">
-            <a:avLst/>
-          </a:prstGeom>
-          <a:noFill/>
-        </p:spPr>
-        <p:txBody>
-          <a:bodyPr wrap="square">
-            <a:spAutoFit/>
-          </a:bodyPr>
-          <a:lstStyle/>
-          <a:p>
-            <a:pPr>
-              <a:spcAft>
-                <a:spcPts val="1000"/>
-              </a:spcAft>
-              <a:defRPr sz="1500">
-                <a:solidFill>
-                  <a:srgbClr val="F8FAFC"/>
-                </a:solidFill>
-                <a:latin typeface="Arial"/>
-              </a:defRPr>
-            </a:pPr>
-            <a:r>
-              <a:t>Backend Engine (server.py): FastAPI with uvicorn running asynchronous ring buffers.</a:t>
-            </a:r>
-          </a:p>
-          <a:p>
-            <a:pPr>
-              <a:spcAft>
-                <a:spcPts val="1000"/>
-              </a:spcAft>
-              <a:defRPr sz="1500">
-                <a:solidFill>
-                  <a:srgbClr val="F8FAFC"/>
-                </a:solidFill>
-                <a:latin typeface="Arial"/>
-              </a:defRPr>
-            </a:pPr>
-            <a:r>
-              <a:t>DSP Thread: 25 Hz sliding window analysis with Levinson-Durbin LPC &amp; autocorrelation.</a:t>
-            </a:r>
-          </a:p>
-          <a:p>
-            <a:pPr>
-              <a:spcAft>
-                <a:spcPts val="1000"/>
-              </a:spcAft>
-              <a:defRPr sz="1500">
-                <a:solidFill>
-                  <a:srgbClr val="F8FAFC"/>
-                </a:solidFill>
-                <a:latin typeface="Arial"/>
-              </a:defRPr>
-            </a:pPr>
-            <a:r>
-              <a:t>Zero-Drop WebSocket Hub: Non-blocking client broadcasts with auto-dropping stale frames.</a:t>
-            </a:r>
-          </a:p>
-          <a:p>
-            <a:pPr>
-              <a:spcAft>
-                <a:spcPts val="1000"/>
-              </a:spcAft>
-              <a:defRPr sz="1500">
-                <a:solidFill>
-                  <a:srgbClr val="F8FAFC"/>
-                </a:solidFill>
-                <a:latin typeface="Arial"/>
-              </a:defRPr>
-            </a:pPr>
-            <a:r>
-              <a:t>Clinical HUD (Next.js 15): Real-time vocal stability radar, formant gauges, &amp; emergency dispatch banners.</a:t>
-            </a:r>
-          </a:p>
-          <a:p>
-            <a:pPr>
-              <a:spcAft>
-                <a:spcPts val="1000"/>
-              </a:spcAft>
-              <a:defRPr sz="1500">
-                <a:solidFill>
-                  <a:srgbClr val="F8FAFC"/>
-                </a:solidFill>
-                <a:latin typeface="Arial"/>
-              </a:defRPr>
-            </a:pPr>
-            <a:r>
-              <a:t>Hardware Independence: Operates seamlessly on standard laptop microphones &amp; telephony audio.</a:t>
-            </a:r>
-          </a:p>
-        </p:txBody>
-      </p:sp>
-      <p:sp>
-        <p:nvSpPr>
-          <p:cNvPr id="8" name="Rounded Rectangle 7"/>
-          <p:cNvSpPr/>
-          <p:nvPr/>
-        </p:nvSpPr>
-        <p:spPr>
-          <a:xfrm>
-            <a:off x="731520" y="5577840"/>
-            <a:ext cx="10728655" cy="731520"/>
+            <a:off x="4480560" y="1645920"/>
+            <a:ext cx="3291840" cy="1645920"/>
           </a:xfrm>
           <a:prstGeom prst="roundRect">
             <a:avLst/>
           </a:prstGeom>
           <a:solidFill>
-            <a:srgbClr val="0F172A"/>
+            <a:srgbClr val="1E293B"/>
           </a:solidFill>
           <a:ln w="12700">
             <a:solidFill>
-              <a:srgbClr val="06B6D4"/>
+              <a:srgbClr val="38BDF8"/>
             </a:solidFill>
           </a:ln>
         </p:spPr>
@@ -5373,45 +5011,205 @@
           </a:fontRef>
         </p:style>
         <p:txBody>
-          <a:bodyPr rtlCol="0" anchor="ctr"/>
-          <a:lstStyle/>
-          <a:p>
-            <a:pPr algn="ctr"/>
-          </a:p>
-        </p:txBody>
-      </p:sp>
-      <p:sp>
-        <p:nvSpPr>
-          <p:cNvPr id="9" name="TextBox 8"/>
-          <p:cNvSpPr txBox="1"/>
+          <a:bodyPr rtlCol="0" anchor="ctr" wrap="square"/>
+          <a:lstStyle/>
+          <a:p>
+            <a:pPr algn="ctr">
+              <a:defRPr sz="3600" b="1">
+                <a:solidFill>
+                  <a:srgbClr val="38BDF8"/>
+                </a:solidFill>
+                <a:latin typeface="Calibri"/>
+              </a:defRPr>
+            </a:pPr>
+            <a:r>
+              <a:t>40.00 ms</a:t>
+            </a:r>
+          </a:p>
+          <a:p>
+            <a:pPr>
+              <a:defRPr sz="1400" b="1">
+                <a:solidFill>
+                  <a:srgbClr val="FFFFFF"/>
+                </a:solidFill>
+                <a:latin typeface="Calibri"/>
+              </a:defRPr>
+            </a:pPr>
+            <a:r>
+              <a:t>Average Packet Interval</a:t>
+            </a:r>
+          </a:p>
+          <a:p>
+            <a:pPr>
+              <a:defRPr sz="1100">
+                <a:solidFill>
+                  <a:srgbClr val="94A3B8"/>
+                </a:solidFill>
+                <a:latin typeface="Calibri"/>
+              </a:defRPr>
+            </a:pPr>
+            <a:r>
+              <a:t>Standard deviation: 0.54 ms</a:t>
+            </a:r>
+          </a:p>
+        </p:txBody>
+      </p:sp>
+      <p:sp>
+        <p:nvSpPr>
+          <p:cNvPr id="6" name="Rounded Rectangle 5"/>
+          <p:cNvSpPr/>
           <p:nvPr/>
         </p:nvSpPr>
         <p:spPr>
           <a:xfrm>
-            <a:off x="914400" y="5715000"/>
-            <a:ext cx="10332720" cy="457200"/>
+            <a:off x="8046720" y="1645920"/>
+            <a:ext cx="3291840" cy="1645920"/>
           </a:xfrm>
-          <a:prstGeom prst="rect">
+          <a:prstGeom prst="roundRect">
             <a:avLst/>
           </a:prstGeom>
-          <a:noFill/>
+          <a:solidFill>
+            <a:srgbClr val="1E293B"/>
+          </a:solidFill>
+          <a:ln w="12700">
+            <a:solidFill>
+              <a:srgbClr val="38BDF8"/>
+            </a:solidFill>
+          </a:ln>
         </p:spPr>
-        <p:txBody>
-          <a:bodyPr wrap="square">
-            <a:spAutoFit/>
-          </a:bodyPr>
-          <a:lstStyle/>
+        <p:style>
+          <a:lnRef idx="1">
+            <a:schemeClr val="accent1"/>
+          </a:lnRef>
+          <a:fillRef idx="3">
+            <a:schemeClr val="accent1"/>
+          </a:fillRef>
+          <a:effectRef idx="2">
+            <a:schemeClr val="accent1"/>
+          </a:effectRef>
+          <a:fontRef idx="minor">
+            <a:schemeClr val="lt1"/>
+          </a:fontRef>
+        </p:style>
+        <p:txBody>
+          <a:bodyPr rtlCol="0" anchor="ctr" wrap="square"/>
+          <a:lstStyle/>
+          <a:p>
+            <a:pPr algn="ctr">
+              <a:defRPr sz="3600" b="1">
+                <a:solidFill>
+                  <a:srgbClr val="38BDF8"/>
+                </a:solidFill>
+                <a:latin typeface="Calibri"/>
+              </a:defRPr>
+            </a:pPr>
+            <a:r>
+              <a:t>0.62 ms</a:t>
+            </a:r>
+          </a:p>
           <a:p>
             <a:pPr>
-              <a:defRPr sz="1300" b="1">
-                <a:solidFill>
-                  <a:srgbClr val="06B6D4"/>
-                </a:solidFill>
-                <a:latin typeface="Arial"/>
+              <a:defRPr sz="1400" b="1">
+                <a:solidFill>
+                  <a:srgbClr val="FFFFFF"/>
+                </a:solidFill>
+                <a:latin typeface="Calibri"/>
               </a:defRPr>
             </a:pPr>
             <a:r>
-              <a:t>⚡  25 Hz Telemetry Broadcast | &lt; 40ms Packet Latency | 0 ms Client Drift</a:t>
+              <a:t>Total Clock Drift</a:t>
+            </a:r>
+          </a:p>
+          <a:p>
+            <a:pPr>
+              <a:defRPr sz="1100">
+                <a:solidFill>
+                  <a:srgbClr val="94A3B8"/>
+                </a:solidFill>
+                <a:latin typeface="Calibri"/>
+              </a:defRPr>
+            </a:pPr>
+            <a:r>
+              <a:t>Zero latency accumulation over 4.0s</a:t>
+            </a:r>
+          </a:p>
+        </p:txBody>
+      </p:sp>
+      <p:sp>
+        <p:nvSpPr>
+          <p:cNvPr id="7" name="Rounded Rectangle 6"/>
+          <p:cNvSpPr/>
+          <p:nvPr/>
+        </p:nvSpPr>
+        <p:spPr>
+          <a:xfrm>
+            <a:off x="914400" y="3566160"/>
+            <a:ext cx="10332720" cy="2560320"/>
+          </a:xfrm>
+          <a:prstGeom prst="roundRect">
+            <a:avLst/>
+          </a:prstGeom>
+          <a:solidFill>
+            <a:srgbClr val="1E293B"/>
+          </a:solidFill>
+          <a:ln>
+            <a:solidFill>
+              <a:srgbClr val="334155"/>
+            </a:solidFill>
+          </a:ln>
+        </p:spPr>
+        <p:style>
+          <a:lnRef idx="1">
+            <a:schemeClr val="accent1"/>
+          </a:lnRef>
+          <a:fillRef idx="3">
+            <a:schemeClr val="accent1"/>
+          </a:fillRef>
+          <a:effectRef idx="2">
+            <a:schemeClr val="accent1"/>
+          </a:effectRef>
+          <a:fontRef idx="minor">
+            <a:schemeClr val="lt1"/>
+          </a:fontRef>
+        </p:style>
+        <p:txBody>
+          <a:bodyPr rtlCol="0" anchor="ctr" wrap="square"/>
+          <a:lstStyle/>
+          <a:p>
+            <a:pPr algn="ctr">
+              <a:defRPr sz="1500" b="1">
+                <a:solidFill>
+                  <a:srgbClr val="34D399"/>
+                </a:solidFill>
+                <a:latin typeface="Calibri"/>
+              </a:defRPr>
+            </a:pPr>
+            <a:r>
+              <a:t>HOW WE PREVENTED AUDIO LATENCY PILEUP</a:t>
+            </a:r>
+          </a:p>
+          <a:p>
+            <a:pPr>
+              <a:spcBef>
+                <a:spcPts val="600"/>
+              </a:spcBef>
+              <a:defRPr sz="1300">
+                <a:solidFill>
+                  <a:srgbClr val="FFFFFF"/>
+                </a:solidFill>
+                <a:latin typeface="Calibri"/>
+              </a:defRPr>
+            </a:pPr>
+            <a:r>
+              <a:t>1. Circular Ring Buffer: A 16 kHz fixed audio buffer holds the most recent 0.5 seconds of audio. New microphone samples overwrite the oldest samples in O(1) time.</a:t>
+            </a:r>
+            <a:br/>
+            <a:r>
+              <a:t>2. Non-blocking WebSocket Dispatch: In server.py, we broadcast to clients with a 35ms timeout. If a client device temporarily slows down, stale packets are dropped rather than buffered.</a:t>
+            </a:r>
+            <a:br/>
+            <a:r>
+              <a:t>3. Hardware-Independent: Works with built-in laptop microphones, smartphone mics, or standard phone lines without needing medical sensors.</a:t>
             </a:r>
           </a:p>
         </p:txBody>
@@ -5449,7 +5247,7 @@
             <a:avLst/>
           </a:prstGeom>
           <a:solidFill>
-            <a:srgbClr val="090D16"/>
+            <a:srgbClr val="0F172A"/>
           </a:solidFill>
           <a:ln>
             <a:noFill/>
@@ -5485,8 +5283,8 @@
         </p:nvSpPr>
         <p:spPr>
           <a:xfrm>
-            <a:off x="731520" y="457200"/>
-            <a:ext cx="10698480" cy="365760"/>
+            <a:off x="914400" y="548640"/>
+            <a:ext cx="10332720" cy="914400"/>
           </a:xfrm>
           <a:prstGeom prst="rect">
             <a:avLst/>
@@ -5494,117 +5292,58 @@
           <a:noFill/>
         </p:spPr>
         <p:txBody>
-          <a:bodyPr wrap="square">
+          <a:bodyPr wrap="none">
             <a:spAutoFit/>
           </a:bodyPr>
           <a:lstStyle/>
           <a:p>
             <a:pPr>
-              <a:defRPr sz="1100" b="1">
-                <a:solidFill>
-                  <a:srgbClr val="06B6D4"/>
-                </a:solidFill>
-                <a:latin typeface="Arial"/>
+              <a:defRPr sz="2800" b="1">
+                <a:solidFill>
+                  <a:srgbClr val="FFFFFF"/>
+                </a:solidFill>
+                <a:latin typeface="Calibri"/>
               </a:defRPr>
             </a:pPr>
             <a:r>
-              <a:t>COMPETITIVE ADVANTAGE &amp; ROADMAP</a:t>
-            </a:r>
-          </a:p>
-        </p:txBody>
-      </p:sp>
-      <p:sp>
-        <p:nvSpPr>
-          <p:cNvPr id="4" name="TextBox 3"/>
-          <p:cNvSpPr txBox="1"/>
+              <a:t>How to Test Our Project Live</a:t>
+            </a:r>
+          </a:p>
+          <a:p>
+            <a:pPr>
+              <a:defRPr sz="1400">
+                <a:solidFill>
+                  <a:srgbClr val="94A3B8"/>
+                </a:solidFill>
+                <a:latin typeface="Calibri"/>
+              </a:defRPr>
+            </a:pPr>
+            <a:r>
+              <a:t>Everything is ready to run locally right now.</a:t>
+            </a:r>
+          </a:p>
+        </p:txBody>
+      </p:sp>
+      <p:sp>
+        <p:nvSpPr>
+          <p:cNvPr id="4" name="Rounded Rectangle 3"/>
+          <p:cNvSpPr/>
           <p:nvPr/>
         </p:nvSpPr>
         <p:spPr>
           <a:xfrm>
-            <a:off x="731520" y="777240"/>
-            <a:ext cx="10698480" cy="640080"/>
-          </a:xfrm>
-          <a:prstGeom prst="rect">
-            <a:avLst/>
-          </a:prstGeom>
-          <a:noFill/>
-        </p:spPr>
-        <p:txBody>
-          <a:bodyPr wrap="square">
-            <a:spAutoFit/>
-          </a:bodyPr>
-          <a:lstStyle/>
-          <a:p>
-            <a:pPr>
-              <a:defRPr sz="2800" b="1">
-                <a:solidFill>
-                  <a:srgbClr val="F8FAFC"/>
-                </a:solidFill>
-                <a:latin typeface="Arial"/>
-              </a:defRPr>
-            </a:pPr>
-            <a:r>
-              <a:t>Why NeuroVocal Wins Hackering 2.0</a:t>
-            </a:r>
-          </a:p>
-        </p:txBody>
-      </p:sp>
-      <p:sp>
-        <p:nvSpPr>
-          <p:cNvPr id="5" name="TextBox 4"/>
-          <p:cNvSpPr txBox="1"/>
-          <p:nvPr/>
-        </p:nvSpPr>
-        <p:spPr>
-          <a:xfrm>
-            <a:off x="731520" y="1371600"/>
-            <a:ext cx="10698480" cy="457200"/>
-          </a:xfrm>
-          <a:prstGeom prst="rect">
-            <a:avLst/>
-          </a:prstGeom>
-          <a:noFill/>
-        </p:spPr>
-        <p:txBody>
-          <a:bodyPr wrap="square">
-            <a:spAutoFit/>
-          </a:bodyPr>
-          <a:lstStyle/>
-          <a:p>
-            <a:pPr>
-              <a:defRPr sz="1400">
-                <a:solidFill>
-                  <a:srgbClr val="94A3B8"/>
-                </a:solidFill>
-                <a:latin typeface="Arial"/>
-              </a:defRPr>
-            </a:pPr>
-            <a:r>
-              <a:t>Unmatched technical depth, tangible clinical utility, and immediate visual impact</a:t>
-            </a:r>
-          </a:p>
-        </p:txBody>
-      </p:sp>
-      <p:sp>
-        <p:nvSpPr>
-          <p:cNvPr id="6" name="Rounded Rectangle 5"/>
-          <p:cNvSpPr/>
-          <p:nvPr/>
-        </p:nvSpPr>
-        <p:spPr>
-          <a:xfrm>
-            <a:off x="731520" y="1920240"/>
-            <a:ext cx="10728655" cy="3474720"/>
+            <a:off x="914400" y="1645920"/>
+            <a:ext cx="10332720" cy="4389120"/>
           </a:xfrm>
           <a:prstGeom prst="roundRect">
             <a:avLst/>
           </a:prstGeom>
           <a:solidFill>
-            <a:srgbClr val="121826"/>
+            <a:srgbClr val="1E293B"/>
           </a:solidFill>
           <a:ln w="12700">
             <a:solidFill>
-              <a:srgbClr val="1E293B"/>
+              <a:srgbClr val="38BDF8"/>
             </a:solidFill>
           </a:ln>
         </p:spPr>
@@ -5623,193 +5362,71 @@
           </a:fontRef>
         </p:style>
         <p:txBody>
-          <a:bodyPr rtlCol="0" anchor="ctr"/>
-          <a:lstStyle/>
-          <a:p>
-            <a:pPr algn="ctr"/>
-          </a:p>
-        </p:txBody>
-      </p:sp>
-      <p:sp>
-        <p:nvSpPr>
-          <p:cNvPr id="7" name="TextBox 6"/>
-          <p:cNvSpPr txBox="1"/>
-          <p:nvPr/>
-        </p:nvSpPr>
-        <p:spPr>
-          <a:xfrm>
-            <a:off x="1005840" y="2103120"/>
-            <a:ext cx="10149840" cy="3108960"/>
-          </a:xfrm>
-          <a:prstGeom prst="rect">
-            <a:avLst/>
-          </a:prstGeom>
-          <a:noFill/>
-        </p:spPr>
-        <p:txBody>
-          <a:bodyPr wrap="square">
-            <a:spAutoFit/>
-          </a:bodyPr>
-          <a:lstStyle/>
-          <a:p>
+          <a:bodyPr rtlCol="0" anchor="ctr" wrap="square"/>
+          <a:lstStyle/>
+          <a:p>
+            <a:pPr algn="ctr">
+              <a:defRPr sz="1600" b="1">
+                <a:solidFill>
+                  <a:srgbClr val="38BDF8"/>
+                </a:solidFill>
+                <a:latin typeface="Calibri"/>
+              </a:defRPr>
+            </a:pPr>
+            <a:r>
+              <a:t>RUNNING THE SYSTEM (3 SIMPLE STEPS)</a:t>
+            </a:r>
+          </a:p>
+          <a:p>
+            <a:br/>
             <a:pPr>
-              <a:spcAft>
-                <a:spcPts val="1000"/>
-              </a:spcAft>
-              <a:defRPr sz="1500">
-                <a:solidFill>
-                  <a:srgbClr val="F8FAFC"/>
-                </a:solidFill>
-                <a:latin typeface="Arial"/>
+              <a:defRPr sz="1400">
+                <a:solidFill>
+                  <a:srgbClr val="FFFFFF"/>
+                </a:solidFill>
+                <a:latin typeface="Calibri"/>
               </a:defRPr>
             </a:pPr>
             <a:r>
-              <a:t>Zero Hardware Overhead: Works across standard PSTN/VoIP phone calls without wearables.</a:t>
-            </a:r>
-          </a:p>
-          <a:p>
-            <a:pPr>
-              <a:spcAft>
-                <a:spcPts val="1000"/>
-              </a:spcAft>
-              <a:defRPr sz="1500">
-                <a:solidFill>
-                  <a:srgbClr val="F8FAFC"/>
-                </a:solidFill>
-                <a:latin typeface="Arial"/>
-              </a:defRPr>
-            </a:pPr>
-            <a:r>
-              <a:t>Deep Tech Differentiation: Mathematical audio signal processing paired with agentic intelligence.</a:t>
-            </a:r>
-          </a:p>
-          <a:p>
-            <a:pPr>
-              <a:spcAft>
-                <a:spcPts val="1000"/>
-              </a:spcAft>
-              <a:defRPr sz="1500">
-                <a:solidFill>
-                  <a:srgbClr val="F8FAFC"/>
-                </a:solidFill>
-                <a:latin typeface="Arial"/>
-              </a:defRPr>
-            </a:pPr>
-            <a:r>
-              <a:t>Phase 1 Validated: Complete 25 Hz WebSocket server + DSP biomarker engine + zero-latency test suite.</a:t>
-            </a:r>
-          </a:p>
-          <a:p>
-            <a:pPr>
-              <a:spcAft>
-                <a:spcPts val="1000"/>
-              </a:spcAft>
-              <a:defRPr sz="1500">
-                <a:solidFill>
-                  <a:srgbClr val="F8FAFC"/>
-                </a:solidFill>
-                <a:latin typeface="Arial"/>
-              </a:defRPr>
-            </a:pPr>
-            <a:r>
-              <a:t>Phase 2 Next.js HUD: High-density clinical telemetry dashboard for 911/112 emergency dispatchers.</a:t>
-            </a:r>
-          </a:p>
-          <a:p>
-            <a:pPr>
-              <a:spcAft>
-                <a:spcPts val="1000"/>
-              </a:spcAft>
-              <a:defRPr sz="1500">
-                <a:solidFill>
-                  <a:srgbClr val="F8FAFC"/>
-                </a:solidFill>
-                <a:latin typeface="Arial"/>
-              </a:defRPr>
-            </a:pPr>
-            <a:r>
-              <a:t>Future Horizon: Integration with Computer-Aided Dispatch (CAD) systems and ambulance telemetry.</a:t>
-            </a:r>
-          </a:p>
-        </p:txBody>
-      </p:sp>
-      <p:sp>
-        <p:nvSpPr>
-          <p:cNvPr id="8" name="Rounded Rectangle 7"/>
-          <p:cNvSpPr/>
-          <p:nvPr/>
-        </p:nvSpPr>
-        <p:spPr>
-          <a:xfrm>
-            <a:off x="731520" y="5577840"/>
-            <a:ext cx="10728655" cy="731520"/>
-          </a:xfrm>
-          <a:prstGeom prst="roundRect">
-            <a:avLst/>
-          </a:prstGeom>
-          <a:solidFill>
-            <a:srgbClr val="0F172A"/>
-          </a:solidFill>
-          <a:ln w="12700">
-            <a:solidFill>
-              <a:srgbClr val="06B6D4"/>
-            </a:solidFill>
-          </a:ln>
-        </p:spPr>
-        <p:style>
-          <a:lnRef idx="1">
-            <a:schemeClr val="accent1"/>
-          </a:lnRef>
-          <a:fillRef idx="3">
-            <a:schemeClr val="accent1"/>
-          </a:fillRef>
-          <a:effectRef idx="2">
-            <a:schemeClr val="accent1"/>
-          </a:effectRef>
-          <a:fontRef idx="minor">
-            <a:schemeClr val="lt1"/>
-          </a:fontRef>
-        </p:style>
-        <p:txBody>
-          <a:bodyPr rtlCol="0" anchor="ctr"/>
-          <a:lstStyle/>
-          <a:p>
-            <a:pPr algn="ctr"/>
-          </a:p>
-        </p:txBody>
-      </p:sp>
-      <p:sp>
-        <p:nvSpPr>
-          <p:cNvPr id="9" name="TextBox 8"/>
-          <p:cNvSpPr txBox="1"/>
-          <p:nvPr/>
-        </p:nvSpPr>
-        <p:spPr>
-          <a:xfrm>
-            <a:off x="914400" y="5715000"/>
-            <a:ext cx="10332720" cy="457200"/>
-          </a:xfrm>
-          <a:prstGeom prst="rect">
-            <a:avLst/>
-          </a:prstGeom>
-          <a:noFill/>
-        </p:spPr>
-        <p:txBody>
-          <a:bodyPr wrap="square">
-            <a:spAutoFit/>
-          </a:bodyPr>
-          <a:lstStyle/>
-          <a:p>
-            <a:pPr>
-              <a:defRPr sz="1300" b="1">
-                <a:solidFill>
-                  <a:srgbClr val="06B6D4"/>
-                </a:solidFill>
-                <a:latin typeface="Arial"/>
-              </a:defRPr>
-            </a:pPr>
-            <a:r>
-              <a:t>⚡  NeuroVocal AI: Giving voice to the silent symptoms of emergency callers.</a:t>
+              <a:t>1. Launch the Backend Server:</a:t>
+            </a:r>
+            <a:br/>
+            <a:r>
+              <a:t>   &gt; python server.py</a:t>
+            </a:r>
+            <a:br/>
+            <a:r>
+              <a:t>   Starts the FastAPI WebSocket server on http://localhost:8000 and taps the laptop microphone.</a:t>
+            </a:r>
+            <a:br/>
+            <a:br/>
+            <a:r>
+              <a:t>2. Open the Dispatcher HUD in Browser:</a:t>
+            </a:r>
+            <a:br/>
+            <a:r>
+              <a:t>   &gt; Visit http://localhost:8000/client</a:t>
+            </a:r>
+            <a:br/>
+            <a:r>
+              <a:t>   Watch live F0, Jitter, HNR, and Formants stream at 25 Hz.</a:t>
+            </a:r>
+            <a:br/>
+            <a:r>
+              <a:t>   Click 'Stroke / Dysarthria' to watch the CSI score jump to 0.80 and trigger the CODE RED emergency alert.</a:t>
+            </a:r>
+            <a:br/>
+            <a:br/>
+            <a:r>
+              <a:t>3. Run the Automated Latency Benchmark:</a:t>
+            </a:r>
+            <a:br/>
+            <a:r>
+              <a:t>   &gt; python test_client.py</a:t>
+            </a:r>
+            <a:br/>
+            <a:r>
+              <a:t>   Measures 100 consecutive frames to verify 25 Hz streaming and 0 ms latency drift.</a:t>
             </a:r>
           </a:p>
         </p:txBody>

</xml_diff>